<commit_message>
docs(apresentacao): remove info de doutorado e move "Veremos ao vivo" para o encerramento
Capa/rodape sem "Doutorado PPGEC" (programa = TAES / disciplina). Tira "Veremos ao
vivo" do slide da jornada e coloca como mensagem do ultimo slide (Obrigado).

Co-Authored-By: Claude Opus 4.8 <noreply@anthropic.com>
</commit_message>
<xml_diff>
--- a/atividades/apresentacoes/ObiOne_Apresentacao_Final.pptx
+++ b/atividades/apresentacoes/ObiOne_Apresentacao_Final.pptx
@@ -3492,7 +3492,7 @@
                 </a:solidFill>
                 <a:latin typeface="Arial"/>
               </a:rPr>
-              <a:t>Doutorado PPGEC · Tópicos Avançados em Engenharia de Software</a:t>
+              <a:t>Tópicos Avançados em Engenharia de Software</a:t>
             </a:r>
           </a:p>
         </p:txBody>
@@ -3623,7 +3623,7 @@
                 </a:solidFill>
                 <a:latin typeface="Arial"/>
               </a:rPr>
-              <a:t>Bruno Rocha · Cynthia Oliveira · Moisés Júnior · Raniel Silva · Doutorado PPGEC · UPE/POLI · Julho 2026</a:t>
+              <a:t>Bruno Rocha · Cynthia Oliveira · Moisés Júnior · Raniel Silva · TAES · UPE/POLI · Julho 2026</a:t>
             </a:r>
           </a:p>
         </p:txBody>
@@ -4620,7 +4620,7 @@
                 </a:solidFill>
                 <a:latin typeface="Arial"/>
               </a:rPr>
-              <a:t>Bruno Rocha · Cynthia Oliveira · Moisés Júnior · Raniel Silva · Doutorado PPGEC · UPE/POLI · Julho 2026</a:t>
+              <a:t>Bruno Rocha · Cynthia Oliveira · Moisés Júnior · Raniel Silva · TAES · UPE/POLI · Julho 2026</a:t>
             </a:r>
           </a:p>
         </p:txBody>
@@ -5311,7 +5311,7 @@
                 </a:solidFill>
                 <a:latin typeface="Arial"/>
               </a:rPr>
-              <a:t>Discussão e perguntas</a:t>
+              <a:t>Veremos ao vivo</a:t>
             </a:r>
           </a:p>
         </p:txBody>
@@ -5346,7 +5346,7 @@
                 </a:solidFill>
                 <a:latin typeface="Arial"/>
               </a:rPr>
-              <a:t>Bruno Rocha · Cynthia Oliveira · Moisés Júnior · Raniel Silva  ·  Doutorado PPGEC  ·  UPE/POLI</a:t>
+              <a:t>Bruno Rocha · Cynthia Oliveira · Moisés Júnior · Raniel Silva  ·  TAES  ·  UPE/POLI</a:t>
             </a:r>
           </a:p>
         </p:txBody>
@@ -6300,7 +6300,7 @@
                 </a:solidFill>
                 <a:latin typeface="Arial"/>
               </a:rPr>
-              <a:t>Bruno Rocha · Cynthia Oliveira · Moisés Júnior · Raniel Silva · Doutorado PPGEC · UPE/POLI · Julho 2026</a:t>
+              <a:t>Bruno Rocha · Cynthia Oliveira · Moisés Júnior · Raniel Silva · TAES · UPE/POLI · Julho 2026</a:t>
             </a:r>
           </a:p>
         </p:txBody>
@@ -6420,7 +6420,7 @@
                 </a:solidFill>
                 <a:latin typeface="Arial"/>
               </a:rPr>
-              <a:t>Bruno Rocha · Cynthia Oliveira · Moisés Júnior · Raniel Silva · Doutorado PPGEC · UPE/POLI · Julho 2026</a:t>
+              <a:t>Bruno Rocha · Cynthia Oliveira · Moisés Júnior · Raniel Silva · TAES · UPE/POLI · Julho 2026</a:t>
             </a:r>
           </a:p>
         </p:txBody>
@@ -6882,7 +6882,7 @@
                 </a:solidFill>
                 <a:latin typeface="Arial"/>
               </a:rPr>
-              <a:t>Bruno Rocha · Cynthia Oliveira · Moisés Júnior · Raniel Silva · Doutorado PPGEC · UPE/POLI · Julho 2026</a:t>
+              <a:t>Bruno Rocha · Cynthia Oliveira · Moisés Júnior · Raniel Silva · TAES · UPE/POLI · Julho 2026</a:t>
             </a:r>
           </a:p>
         </p:txBody>
@@ -7437,7 +7437,7 @@
                 </a:solidFill>
                 <a:latin typeface="Arial"/>
               </a:rPr>
-              <a:t>Bruno Rocha · Cynthia Oliveira · Moisés Júnior · Raniel Silva · Doutorado PPGEC · UPE/POLI · Julho 2026</a:t>
+              <a:t>Bruno Rocha · Cynthia Oliveira · Moisés Júnior · Raniel Silva · TAES · UPE/POLI · Julho 2026</a:t>
             </a:r>
           </a:p>
         </p:txBody>
@@ -8082,16 +8082,7 @@
                 </a:solidFill>
                 <a:latin typeface="Arial"/>
               </a:rPr>
-              <a:t>A IA acelera as pontas trabalhosas; o consultor decide. </a:t>
-            </a:r>
-            <a:r>
-              <a:rPr sz="1600" b="1" i="0">
-                <a:solidFill>
-                  <a:srgbClr val="1F2A44"/>
-                </a:solidFill>
-                <a:latin typeface="Arial"/>
-              </a:rPr>
-              <a:t>Veremos ao vivo.</a:t>
+              <a:t>A IA acelera as pontas trabalhosas; o consultor decide.</a:t>
             </a:r>
           </a:p>
         </p:txBody>
@@ -8176,7 +8167,7 @@
                 </a:solidFill>
                 <a:latin typeface="Arial"/>
               </a:rPr>
-              <a:t>Bruno Rocha · Cynthia Oliveira · Moisés Júnior · Raniel Silva · Doutorado PPGEC · UPE/POLI · Julho 2026</a:t>
+              <a:t>Bruno Rocha · Cynthia Oliveira · Moisés Júnior · Raniel Silva · TAES · UPE/POLI · Julho 2026</a:t>
             </a:r>
           </a:p>
         </p:txBody>
@@ -8477,7 +8468,7 @@
                 </a:solidFill>
                 <a:latin typeface="Arial"/>
               </a:rPr>
-              <a:t>Bruno Rocha · Cynthia Oliveira · Moisés Júnior · Raniel Silva · Doutorado PPGEC · UPE/POLI · Julho 2026</a:t>
+              <a:t>Bruno Rocha · Cynthia Oliveira · Moisés Júnior · Raniel Silva · TAES · UPE/POLI · Julho 2026</a:t>
             </a:r>
           </a:p>
         </p:txBody>
@@ -8660,7 +8651,7 @@
       </p:sp>
       <p:pic>
         <p:nvPicPr>
-          <p:cNvPr id="44" name="Picture 43" descr="aprendizados_dominio_bloco.png"/>
+          <p:cNvPr id="44" name="Picture 43" descr="image.png"/>
           <p:cNvPicPr>
             <a:picLocks noChangeAspect="1"/>
           </p:cNvPicPr>
@@ -8743,7 +8734,7 @@
                 </a:solidFill>
                 <a:latin typeface="Arial"/>
               </a:rPr>
-              <a:t>Bruno Rocha · Cynthia Oliveira · Moisés Júnior · Raniel Silva · Doutorado PPGEC · UPE/POLI · Julho 2026</a:t>
+              <a:t>Bruno Rocha · Cynthia Oliveira · Moisés Júnior · Raniel Silva · TAES · UPE/POLI · Julho 2026</a:t>
             </a:r>
           </a:p>
         </p:txBody>
@@ -9287,7 +9278,7 @@
                 </a:solidFill>
                 <a:latin typeface="Arial"/>
               </a:rPr>
-              <a:t>Bruno Rocha · Cynthia Oliveira · Moisés Júnior · Raniel Silva · Doutorado PPGEC · UPE/POLI · Julho 2026</a:t>
+              <a:t>Bruno Rocha · Cynthia Oliveira · Moisés Júnior · Raniel Silva · TAES · UPE/POLI · Julho 2026</a:t>
             </a:r>
           </a:p>
         </p:txBody>

</xml_diff>

<commit_message>
docs(apresentacao): slide da camada de IA, experimento em 2 slides, remove redundancias
- Novo slide "A camada de IA" (papeis no ciclo + human-in-the-loop + proveniencia).
- Experimento aprofundado em 2 slides: metodo (DSR, instrumento, amostra N=8) e
  resultados (4,3/5 acumulado, 83% positivas, dimensoes, achado qualitativo).
- Remove slides redundantes (jornada e demo; o ciclo ja esta na solucao).
- Reformula "senior vira gargalo" e alinha a agenda. 11 slides, QC PASS.

Co-Authored-By: Claude Opus 4.8 <noreply@anthropic.com>
</commit_message>
<xml_diff>
--- a/atividades/apresentacoes/ObiOne_Apresentacao_Final.pptx
+++ b/atividades/apresentacoes/ObiOne_Apresentacao_Final.pptx
@@ -15,7 +15,6 @@
     <p:sldId id="278" r:id="rId17"/>
     <p:sldId id="277" r:id="rId16"/>
     <p:sldId id="276" r:id="rId13"/>
-    <p:sldId id="275" r:id="rId14"/>
     <p:sldId id="274" r:id="rId25"/>
   </p:sldIdLst>
   <p:sldSz cx="12192000" cy="6858000" type="screen4x3"/>
@@ -3658,7 +3657,7 @@
                 </a:solidFill>
                 <a:latin typeface="Arial"/>
               </a:rPr>
-              <a:t>10 / 12</a:t>
+              <a:t>10 / 11</a:t>
             </a:r>
           </a:p>
         </p:txBody>
@@ -3721,7 +3720,7 @@
                 </a:solidFill>
                 <a:latin typeface="Arial"/>
               </a:rPr>
-              <a:t>DEMONSTRAÇÃO</a:t>
+              <a:t>VALOR ENTREGUE</a:t>
             </a:r>
           </a:p>
         </p:txBody>
@@ -3735,7 +3734,7 @@
         <p:spPr>
           <a:xfrm>
             <a:off x="502920" y="804672"/>
-            <a:ext cx="10241280" cy="914400"/>
+            <a:ext cx="11155680" cy="914400"/>
           </a:xfrm>
           <a:prstGeom prst="rect">
             <a:avLst/>
@@ -3760,84 +3759,27 @@
                 </a:solidFill>
                 <a:latin typeface="Arial"/>
               </a:rPr>
-              <a:t>Agora, o fluxo real</a:t>
-            </a:r>
-          </a:p>
-        </p:txBody>
-      </p:sp>
-      <p:sp>
-        <p:nvSpPr>
-          <p:cNvPr id="43" name="Oval 42"/>
+              <a:t>A jornada roda de ponta a ponta</a:t>
+            </a:r>
+          </a:p>
+        </p:txBody>
+      </p:sp>
+      <p:sp>
+        <p:nvSpPr>
+          <p:cNvPr id="43" name="Rounded Rectangle 42"/>
           <p:cNvSpPr/>
           <p:nvPr/>
         </p:nvSpPr>
         <p:spPr>
           <a:xfrm>
-            <a:off x="1078992" y="2377439"/>
-            <a:ext cx="512064" cy="512064"/>
-          </a:xfrm>
-          <a:prstGeom prst="ellipse">
+            <a:off x="502920" y="2788920"/>
+            <a:ext cx="2606040" cy="1371600"/>
+          </a:xfrm>
+          <a:prstGeom prst="roundRect">
             <a:avLst/>
           </a:prstGeom>
           <a:solidFill>
-            <a:srgbClr val="E0261E"/>
-          </a:solidFill>
-          <a:ln>
-            <a:noFill/>
-          </a:ln>
-          <a:effectLst/>
-        </p:spPr>
-        <p:style>
-          <a:lnRef idx="1">
-            <a:schemeClr val="accent1"/>
-          </a:lnRef>
-          <a:fillRef idx="3">
-            <a:schemeClr val="accent1"/>
-          </a:fillRef>
-          <a:effectRef idx="2">
-            <a:schemeClr val="accent1"/>
-          </a:effectRef>
-          <a:fontRef idx="minor">
-            <a:schemeClr val="lt1"/>
-          </a:fontRef>
-        </p:style>
-        <p:txBody>
-          <a:bodyPr rtlCol="0" anchor="ctr" wrap="square" lIns="109728" rIns="109728" tIns="54864" bIns="54864"/>
-          <a:lstStyle/>
-          <a:p>
-            <a:pPr algn="ctr">
-              <a:spcAft>
-                <a:spcPts val="200"/>
-              </a:spcAft>
-            </a:pPr>
-            <a:r>
-              <a:rPr sz="1800" b="1">
-                <a:solidFill>
-                  <a:srgbClr val="FFFFFF"/>
-                </a:solidFill>
-                <a:latin typeface="Arial"/>
-              </a:rPr>
-              <a:t>1</a:t>
-            </a:r>
-          </a:p>
-        </p:txBody>
-      </p:sp>
-      <p:sp>
-        <p:nvSpPr>
-          <p:cNvPr id="44" name="Rounded Rectangle 43"/>
-          <p:cNvSpPr/>
-          <p:nvPr/>
-        </p:nvSpPr>
-        <p:spPr>
-          <a:xfrm>
-            <a:off x="457200" y="3017520"/>
-            <a:ext cx="1755648" cy="1371600"/>
-          </a:xfrm>
-          <a:prstGeom prst="roundRect">
-            <a:avLst/>
-          </a:prstGeom>
-          <a:solidFill>
-            <a:srgbClr val="F2F3F5"/>
+            <a:srgbClr val="F6F7F9"/>
           </a:solidFill>
           <a:ln w="12700">
             <a:solidFill>
@@ -3861,115 +3803,58 @@
           </a:fontRef>
         </p:style>
         <p:txBody>
-          <a:bodyPr rtlCol="0" anchor="ctr" wrap="square" lIns="109728" rIns="109728" tIns="54864" bIns="54864"/>
+          <a:bodyPr rtlCol="0" anchor="ctr" wrap="square" lIns="128016" rIns="128016" tIns="54864" bIns="54864"/>
           <a:lstStyle/>
           <a:p>
             <a:pPr algn="ctr">
               <a:spcAft>
-                <a:spcPts val="200"/>
+                <a:spcPts val="300"/>
               </a:spcAft>
             </a:pPr>
             <a:r>
-              <a:rPr sz="1350" b="1">
-                <a:solidFill>
-                  <a:srgbClr val="1F2A44"/>
-                </a:solidFill>
-                <a:latin typeface="Arial"/>
-              </a:rPr>
-              <a:t>Cadastro</a:t>
+              <a:rPr sz="2000" b="1">
+                <a:solidFill>
+                  <a:srgbClr val="2E7D5B"/>
+                </a:solidFill>
+                <a:latin typeface="Arial"/>
+              </a:rPr>
+              <a:t>✓</a:t>
             </a:r>
           </a:p>
           <a:p>
             <a:pPr algn="ctr">
               <a:spcAft>
-                <a:spcPts val="200"/>
+                <a:spcPts val="300"/>
               </a:spcAft>
             </a:pPr>
             <a:r>
-              <a:rPr sz="1350" b="1">
+              <a:rPr sz="1400" b="1">
                 <a:solidFill>
                   <a:srgbClr val="1F2A44"/>
                 </a:solidFill>
                 <a:latin typeface="Arial"/>
               </a:rPr>
-              <a:t>com IA</a:t>
-            </a:r>
-          </a:p>
-        </p:txBody>
-      </p:sp>
-      <p:sp>
-        <p:nvSpPr>
-          <p:cNvPr id="45" name="Oval 44"/>
+              <a:t>Isolamento do cliente</a:t>
+            </a:r>
+          </a:p>
+        </p:txBody>
+      </p:sp>
+      <p:sp>
+        <p:nvSpPr>
+          <p:cNvPr id="44" name="Rounded Rectangle 43"/>
           <p:cNvSpPr/>
           <p:nvPr/>
         </p:nvSpPr>
         <p:spPr>
           <a:xfrm>
-            <a:off x="2962656" y="2377439"/>
-            <a:ext cx="512064" cy="512064"/>
-          </a:xfrm>
-          <a:prstGeom prst="ellipse">
+            <a:off x="3310128" y="2788920"/>
+            <a:ext cx="2606040" cy="1371600"/>
+          </a:xfrm>
+          <a:prstGeom prst="roundRect">
             <a:avLst/>
           </a:prstGeom>
           <a:solidFill>
-            <a:srgbClr val="E0261E"/>
-          </a:solidFill>
-          <a:ln>
-            <a:noFill/>
-          </a:ln>
-          <a:effectLst/>
-        </p:spPr>
-        <p:style>
-          <a:lnRef idx="1">
-            <a:schemeClr val="accent1"/>
-          </a:lnRef>
-          <a:fillRef idx="3">
-            <a:schemeClr val="accent1"/>
-          </a:fillRef>
-          <a:effectRef idx="2">
-            <a:schemeClr val="accent1"/>
-          </a:effectRef>
-          <a:fontRef idx="minor">
-            <a:schemeClr val="lt1"/>
-          </a:fontRef>
-        </p:style>
-        <p:txBody>
-          <a:bodyPr rtlCol="0" anchor="ctr" wrap="square" lIns="109728" rIns="109728" tIns="54864" bIns="54864"/>
-          <a:lstStyle/>
-          <a:p>
-            <a:pPr algn="ctr">
-              <a:spcAft>
-                <a:spcPts val="200"/>
-              </a:spcAft>
-            </a:pPr>
-            <a:r>
-              <a:rPr sz="1800" b="1">
-                <a:solidFill>
-                  <a:srgbClr val="FFFFFF"/>
-                </a:solidFill>
-                <a:latin typeface="Arial"/>
-              </a:rPr>
-              <a:t>2</a:t>
-            </a:r>
-          </a:p>
-        </p:txBody>
-      </p:sp>
-      <p:sp>
-        <p:nvSpPr>
-          <p:cNvPr id="46" name="Rounded Rectangle 45"/>
-          <p:cNvSpPr/>
-          <p:nvPr/>
-        </p:nvSpPr>
-        <p:spPr>
-          <a:xfrm>
-            <a:off x="2340864" y="3017520"/>
-            <a:ext cx="1755648" cy="1371600"/>
-          </a:xfrm>
-          <a:prstGeom prst="roundRect">
-            <a:avLst/>
-          </a:prstGeom>
-          <a:solidFill>
-            <a:srgbClr val="F2F3F5"/>
+            <a:srgbClr val="F6F7F9"/>
           </a:solidFill>
           <a:ln w="12700">
             <a:solidFill>
@@ -3993,99 +3878,58 @@
           </a:fontRef>
         </p:style>
         <p:txBody>
-          <a:bodyPr rtlCol="0" anchor="ctr" wrap="square" lIns="109728" rIns="109728" tIns="54864" bIns="54864"/>
+          <a:bodyPr rtlCol="0" anchor="ctr" wrap="square" lIns="128016" rIns="128016" tIns="54864" bIns="54864"/>
           <a:lstStyle/>
           <a:p>
             <a:pPr algn="ctr">
               <a:spcAft>
-                <a:spcPts val="200"/>
+                <a:spcPts val="300"/>
               </a:spcAft>
             </a:pPr>
             <a:r>
-              <a:rPr sz="1350" b="1">
-                <a:solidFill>
-                  <a:srgbClr val="1F2A44"/>
-                </a:solidFill>
-                <a:latin typeface="Arial"/>
-              </a:rPr>
-              <a:t>Observação</a:t>
-            </a:r>
-          </a:p>
-        </p:txBody>
-      </p:sp>
-      <p:sp>
-        <p:nvSpPr>
-          <p:cNvPr id="47" name="Oval 46"/>
-          <p:cNvSpPr/>
-          <p:nvPr/>
-        </p:nvSpPr>
-        <p:spPr>
-          <a:xfrm>
-            <a:off x="4846320" y="2377439"/>
-            <a:ext cx="512064" cy="512064"/>
-          </a:xfrm>
-          <a:prstGeom prst="ellipse">
-            <a:avLst/>
-          </a:prstGeom>
-          <a:solidFill>
-            <a:srgbClr val="E0261E"/>
-          </a:solidFill>
-          <a:ln>
-            <a:noFill/>
-          </a:ln>
-          <a:effectLst/>
-        </p:spPr>
-        <p:style>
-          <a:lnRef idx="1">
-            <a:schemeClr val="accent1"/>
-          </a:lnRef>
-          <a:fillRef idx="3">
-            <a:schemeClr val="accent1"/>
-          </a:fillRef>
-          <a:effectRef idx="2">
-            <a:schemeClr val="accent1"/>
-          </a:effectRef>
-          <a:fontRef idx="minor">
-            <a:schemeClr val="lt1"/>
-          </a:fontRef>
-        </p:style>
-        <p:txBody>
-          <a:bodyPr rtlCol="0" anchor="ctr" wrap="square" lIns="109728" rIns="109728" tIns="54864" bIns="54864"/>
-          <a:lstStyle/>
+              <a:rPr sz="2000" b="1">
+                <a:solidFill>
+                  <a:srgbClr val="2E7D5B"/>
+                </a:solidFill>
+                <a:latin typeface="Arial"/>
+              </a:rPr>
+              <a:t>✓</a:t>
+            </a:r>
+          </a:p>
           <a:p>
             <a:pPr algn="ctr">
               <a:spcAft>
-                <a:spcPts val="200"/>
+                <a:spcPts val="300"/>
               </a:spcAft>
             </a:pPr>
             <a:r>
-              <a:rPr sz="1800" b="1">
-                <a:solidFill>
-                  <a:srgbClr val="FFFFFF"/>
-                </a:solidFill>
-                <a:latin typeface="Arial"/>
-              </a:rPr>
-              <a:t>3</a:t>
-            </a:r>
-          </a:p>
-        </p:txBody>
-      </p:sp>
-      <p:sp>
-        <p:nvSpPr>
-          <p:cNvPr id="48" name="Rounded Rectangle 47"/>
+              <a:rPr sz="1400" b="1">
+                <a:solidFill>
+                  <a:srgbClr val="1F2A44"/>
+                </a:solidFill>
+                <a:latin typeface="Arial"/>
+              </a:rPr>
+              <a:t>Reaproveitamento</a:t>
+            </a:r>
+          </a:p>
+        </p:txBody>
+      </p:sp>
+      <p:sp>
+        <p:nvSpPr>
+          <p:cNvPr id="45" name="Rounded Rectangle 44"/>
           <p:cNvSpPr/>
           <p:nvPr/>
         </p:nvSpPr>
         <p:spPr>
           <a:xfrm>
-            <a:off x="4224528" y="3017520"/>
-            <a:ext cx="1755648" cy="1371600"/>
+            <a:off x="6117336" y="2788920"/>
+            <a:ext cx="2606040" cy="1371600"/>
           </a:xfrm>
           <a:prstGeom prst="roundRect">
             <a:avLst/>
           </a:prstGeom>
           <a:solidFill>
-            <a:srgbClr val="F2F3F5"/>
+            <a:srgbClr val="F6F7F9"/>
           </a:solidFill>
           <a:ln w="12700">
             <a:solidFill>
@@ -4109,99 +3953,58 @@
           </a:fontRef>
         </p:style>
         <p:txBody>
-          <a:bodyPr rtlCol="0" anchor="ctr" wrap="square" lIns="109728" rIns="109728" tIns="54864" bIns="54864"/>
+          <a:bodyPr rtlCol="0" anchor="ctr" wrap="square" lIns="128016" rIns="128016" tIns="54864" bIns="54864"/>
           <a:lstStyle/>
           <a:p>
             <a:pPr algn="ctr">
               <a:spcAft>
-                <a:spcPts val="200"/>
+                <a:spcPts val="300"/>
               </a:spcAft>
             </a:pPr>
             <a:r>
-              <a:rPr sz="1350" b="1">
-                <a:solidFill>
-                  <a:srgbClr val="1F2A44"/>
-                </a:solidFill>
-                <a:latin typeface="Arial"/>
-              </a:rPr>
-              <a:t>Conversa</a:t>
-            </a:r>
-          </a:p>
-        </p:txBody>
-      </p:sp>
-      <p:sp>
-        <p:nvSpPr>
-          <p:cNvPr id="49" name="Oval 48"/>
-          <p:cNvSpPr/>
-          <p:nvPr/>
-        </p:nvSpPr>
-        <p:spPr>
-          <a:xfrm>
-            <a:off x="6729983" y="2377439"/>
-            <a:ext cx="512064" cy="512064"/>
-          </a:xfrm>
-          <a:prstGeom prst="ellipse">
-            <a:avLst/>
-          </a:prstGeom>
-          <a:solidFill>
-            <a:srgbClr val="E0261E"/>
-          </a:solidFill>
-          <a:ln>
-            <a:noFill/>
-          </a:ln>
-          <a:effectLst/>
-        </p:spPr>
-        <p:style>
-          <a:lnRef idx="1">
-            <a:schemeClr val="accent1"/>
-          </a:lnRef>
-          <a:fillRef idx="3">
-            <a:schemeClr val="accent1"/>
-          </a:fillRef>
-          <a:effectRef idx="2">
-            <a:schemeClr val="accent1"/>
-          </a:effectRef>
-          <a:fontRef idx="minor">
-            <a:schemeClr val="lt1"/>
-          </a:fontRef>
-        </p:style>
-        <p:txBody>
-          <a:bodyPr rtlCol="0" anchor="ctr" wrap="square" lIns="109728" rIns="109728" tIns="54864" bIns="54864"/>
-          <a:lstStyle/>
+              <a:rPr sz="2000" b="1">
+                <a:solidFill>
+                  <a:srgbClr val="2E7D5B"/>
+                </a:solidFill>
+                <a:latin typeface="Arial"/>
+              </a:rPr>
+              <a:t>✓</a:t>
+            </a:r>
+          </a:p>
           <a:p>
             <a:pPr algn="ctr">
               <a:spcAft>
-                <a:spcPts val="200"/>
+                <a:spcPts val="300"/>
               </a:spcAft>
             </a:pPr>
             <a:r>
-              <a:rPr sz="1800" b="1">
-                <a:solidFill>
-                  <a:srgbClr val="FFFFFF"/>
-                </a:solidFill>
-                <a:latin typeface="Arial"/>
-              </a:rPr>
-              <a:t>4</a:t>
-            </a:r>
-          </a:p>
-        </p:txBody>
-      </p:sp>
-      <p:sp>
-        <p:nvSpPr>
-          <p:cNvPr id="50" name="Rounded Rectangle 49"/>
+              <a:rPr sz="1400" b="1">
+                <a:solidFill>
+                  <a:srgbClr val="1F2A44"/>
+                </a:solidFill>
+                <a:latin typeface="Arial"/>
+              </a:rPr>
+              <a:t>Engajamento</a:t>
+            </a:r>
+          </a:p>
+        </p:txBody>
+      </p:sp>
+      <p:sp>
+        <p:nvSpPr>
+          <p:cNvPr id="46" name="Rounded Rectangle 45"/>
           <p:cNvSpPr/>
           <p:nvPr/>
         </p:nvSpPr>
         <p:spPr>
           <a:xfrm>
-            <a:off x="6108192" y="3017520"/>
-            <a:ext cx="1755648" cy="1371600"/>
+            <a:off x="8924544" y="2788920"/>
+            <a:ext cx="2606040" cy="1371600"/>
           </a:xfrm>
           <a:prstGeom prst="roundRect">
             <a:avLst/>
           </a:prstGeom>
           <a:solidFill>
-            <a:srgbClr val="F2F3F5"/>
+            <a:srgbClr val="F6F7F9"/>
           </a:solidFill>
           <a:ln w="12700">
             <a:solidFill>
@@ -4225,316 +4028,52 @@
           </a:fontRef>
         </p:style>
         <p:txBody>
-          <a:bodyPr rtlCol="0" anchor="ctr" wrap="square" lIns="109728" rIns="109728" tIns="54864" bIns="54864"/>
+          <a:bodyPr rtlCol="0" anchor="ctr" wrap="square" lIns="128016" rIns="128016" tIns="54864" bIns="54864"/>
           <a:lstStyle/>
           <a:p>
             <a:pPr algn="ctr">
               <a:spcAft>
-                <a:spcPts val="200"/>
+                <a:spcPts val="300"/>
               </a:spcAft>
             </a:pPr>
             <a:r>
-              <a:rPr sz="1350" b="1">
-                <a:solidFill>
-                  <a:srgbClr val="1F2A44"/>
-                </a:solidFill>
-                <a:latin typeface="Arial"/>
-              </a:rPr>
-              <a:t>Consolidação</a:t>
+              <a:rPr sz="2000" b="1">
+                <a:solidFill>
+                  <a:srgbClr val="2E7D5B"/>
+                </a:solidFill>
+                <a:latin typeface="Arial"/>
+              </a:rPr>
+              <a:t>✓</a:t>
             </a:r>
           </a:p>
           <a:p>
             <a:pPr algn="ctr">
               <a:spcAft>
-                <a:spcPts val="200"/>
+                <a:spcPts val="300"/>
               </a:spcAft>
             </a:pPr>
             <a:r>
-              <a:rPr sz="1350" b="1">
+              <a:rPr sz="1400" b="1">
                 <a:solidFill>
                   <a:srgbClr val="1F2A44"/>
                 </a:solidFill>
                 <a:latin typeface="Arial"/>
               </a:rPr>
-              <a:t>com IA</a:t>
-            </a:r>
-          </a:p>
-        </p:txBody>
-      </p:sp>
-      <p:sp>
-        <p:nvSpPr>
-          <p:cNvPr id="51" name="Oval 50"/>
-          <p:cNvSpPr/>
-          <p:nvPr/>
-        </p:nvSpPr>
-        <p:spPr>
-          <a:xfrm>
-            <a:off x="8613648" y="2377439"/>
-            <a:ext cx="512064" cy="512064"/>
-          </a:xfrm>
-          <a:prstGeom prst="ellipse">
-            <a:avLst/>
-          </a:prstGeom>
-          <a:solidFill>
-            <a:srgbClr val="E0261E"/>
-          </a:solidFill>
-          <a:ln>
-            <a:noFill/>
-          </a:ln>
-          <a:effectLst/>
-        </p:spPr>
-        <p:style>
-          <a:lnRef idx="1">
-            <a:schemeClr val="accent1"/>
-          </a:lnRef>
-          <a:fillRef idx="3">
-            <a:schemeClr val="accent1"/>
-          </a:fillRef>
-          <a:effectRef idx="2">
-            <a:schemeClr val="accent1"/>
-          </a:effectRef>
-          <a:fontRef idx="minor">
-            <a:schemeClr val="lt1"/>
-          </a:fontRef>
-        </p:style>
-        <p:txBody>
-          <a:bodyPr rtlCol="0" anchor="ctr" wrap="square" lIns="109728" rIns="109728" tIns="54864" bIns="54864"/>
-          <a:lstStyle/>
-          <a:p>
-            <a:pPr algn="ctr">
-              <a:spcAft>
-                <a:spcPts val="200"/>
-              </a:spcAft>
-            </a:pPr>
-            <a:r>
-              <a:rPr sz="1800" b="1">
-                <a:solidFill>
-                  <a:srgbClr val="FFFFFF"/>
-                </a:solidFill>
-                <a:latin typeface="Arial"/>
-              </a:rPr>
-              <a:t>5</a:t>
-            </a:r>
-          </a:p>
-        </p:txBody>
-      </p:sp>
-      <p:sp>
-        <p:nvSpPr>
-          <p:cNvPr id="52" name="Rounded Rectangle 51"/>
-          <p:cNvSpPr/>
-          <p:nvPr/>
-        </p:nvSpPr>
-        <p:spPr>
-          <a:xfrm>
-            <a:off x="7991856" y="3017520"/>
-            <a:ext cx="1755648" cy="1371600"/>
-          </a:xfrm>
-          <a:prstGeom prst="roundRect">
-            <a:avLst/>
-          </a:prstGeom>
-          <a:solidFill>
-            <a:srgbClr val="F2F3F5"/>
-          </a:solidFill>
-          <a:ln w="12700">
-            <a:solidFill>
-              <a:srgbClr val="DDE1E7"/>
-            </a:solidFill>
-          </a:ln>
-          <a:effectLst/>
-        </p:spPr>
-        <p:style>
-          <a:lnRef idx="1">
-            <a:schemeClr val="accent1"/>
-          </a:lnRef>
-          <a:fillRef idx="3">
-            <a:schemeClr val="accent1"/>
-          </a:fillRef>
-          <a:effectRef idx="2">
-            <a:schemeClr val="accent1"/>
-          </a:effectRef>
-          <a:fontRef idx="minor">
-            <a:schemeClr val="lt1"/>
-          </a:fontRef>
-        </p:style>
-        <p:txBody>
-          <a:bodyPr rtlCol="0" anchor="ctr" wrap="square" lIns="109728" rIns="109728" tIns="54864" bIns="54864"/>
-          <a:lstStyle/>
-          <a:p>
-            <a:pPr algn="ctr">
-              <a:spcAft>
-                <a:spcPts val="200"/>
-              </a:spcAft>
-            </a:pPr>
-            <a:r>
-              <a:rPr sz="1350" b="1">
-                <a:solidFill>
-                  <a:srgbClr val="1F2A44"/>
-                </a:solidFill>
-                <a:latin typeface="Arial"/>
-              </a:rPr>
-              <a:t>Reaprovei-</a:t>
-            </a:r>
-          </a:p>
-          <a:p>
-            <a:pPr algn="ctr">
-              <a:spcAft>
-                <a:spcPts val="200"/>
-              </a:spcAft>
-            </a:pPr>
-            <a:r>
-              <a:rPr sz="1350" b="1">
-                <a:solidFill>
-                  <a:srgbClr val="1F2A44"/>
-                </a:solidFill>
-                <a:latin typeface="Arial"/>
-              </a:rPr>
-              <a:t>tamento</a:t>
-            </a:r>
-          </a:p>
-        </p:txBody>
-      </p:sp>
-      <p:sp>
-        <p:nvSpPr>
-          <p:cNvPr id="53" name="Oval 52"/>
-          <p:cNvSpPr/>
-          <p:nvPr/>
-        </p:nvSpPr>
-        <p:spPr>
-          <a:xfrm>
-            <a:off x="10497312" y="2377439"/>
-            <a:ext cx="512064" cy="512064"/>
-          </a:xfrm>
-          <a:prstGeom prst="ellipse">
-            <a:avLst/>
-          </a:prstGeom>
-          <a:solidFill>
-            <a:srgbClr val="E0261E"/>
-          </a:solidFill>
-          <a:ln>
-            <a:noFill/>
-          </a:ln>
-          <a:effectLst/>
-        </p:spPr>
-        <p:style>
-          <a:lnRef idx="1">
-            <a:schemeClr val="accent1"/>
-          </a:lnRef>
-          <a:fillRef idx="3">
-            <a:schemeClr val="accent1"/>
-          </a:fillRef>
-          <a:effectRef idx="2">
-            <a:schemeClr val="accent1"/>
-          </a:effectRef>
-          <a:fontRef idx="minor">
-            <a:schemeClr val="lt1"/>
-          </a:fontRef>
-        </p:style>
-        <p:txBody>
-          <a:bodyPr rtlCol="0" anchor="ctr" wrap="square" lIns="109728" rIns="109728" tIns="54864" bIns="54864"/>
-          <a:lstStyle/>
-          <a:p>
-            <a:pPr algn="ctr">
-              <a:spcAft>
-                <a:spcPts val="200"/>
-              </a:spcAft>
-            </a:pPr>
-            <a:r>
-              <a:rPr sz="1800" b="1">
-                <a:solidFill>
-                  <a:srgbClr val="FFFFFF"/>
-                </a:solidFill>
-                <a:latin typeface="Arial"/>
-              </a:rPr>
-              <a:t>6</a:t>
-            </a:r>
-          </a:p>
-        </p:txBody>
-      </p:sp>
-      <p:sp>
-        <p:nvSpPr>
-          <p:cNvPr id="54" name="Rounded Rectangle 53"/>
-          <p:cNvSpPr/>
-          <p:nvPr/>
-        </p:nvSpPr>
-        <p:spPr>
-          <a:xfrm>
-            <a:off x="9875520" y="3017520"/>
-            <a:ext cx="1755648" cy="1371600"/>
-          </a:xfrm>
-          <a:prstGeom prst="roundRect">
-            <a:avLst/>
-          </a:prstGeom>
-          <a:solidFill>
-            <a:srgbClr val="F2F3F5"/>
-          </a:solidFill>
-          <a:ln w="12700">
-            <a:solidFill>
-              <a:srgbClr val="DDE1E7"/>
-            </a:solidFill>
-          </a:ln>
-          <a:effectLst/>
-        </p:spPr>
-        <p:style>
-          <a:lnRef idx="1">
-            <a:schemeClr val="accent1"/>
-          </a:lnRef>
-          <a:fillRef idx="3">
-            <a:schemeClr val="accent1"/>
-          </a:fillRef>
-          <a:effectRef idx="2">
-            <a:schemeClr val="accent1"/>
-          </a:effectRef>
-          <a:fontRef idx="minor">
-            <a:schemeClr val="lt1"/>
-          </a:fontRef>
-        </p:style>
-        <p:txBody>
-          <a:bodyPr rtlCol="0" anchor="ctr" wrap="square" lIns="109728" rIns="109728" tIns="54864" bIns="54864"/>
-          <a:lstStyle/>
-          <a:p>
-            <a:pPr algn="ctr">
-              <a:spcAft>
-                <a:spcPts val="200"/>
-              </a:spcAft>
-            </a:pPr>
-            <a:r>
-              <a:rPr sz="1350" b="1">
-                <a:solidFill>
-                  <a:srgbClr val="1F2A44"/>
-                </a:solidFill>
-                <a:latin typeface="Arial"/>
-              </a:rPr>
-              <a:t>Cliente</a:t>
-            </a:r>
-          </a:p>
-          <a:p>
-            <a:pPr algn="ctr">
-              <a:spcAft>
-                <a:spcPts val="200"/>
-              </a:spcAft>
-            </a:pPr>
-            <a:r>
-              <a:rPr sz="1350" b="1">
-                <a:solidFill>
-                  <a:srgbClr val="1F2A44"/>
-                </a:solidFill>
-                <a:latin typeface="Arial"/>
-              </a:rPr>
-              <a:t>isolado</a:t>
-            </a:r>
-          </a:p>
-        </p:txBody>
-      </p:sp>
-      <p:sp>
-        <p:nvSpPr>
-          <p:cNvPr id="55" name="TextBox 54"/>
+              <a:t>IA copiloto</a:t>
+            </a:r>
+          </a:p>
+        </p:txBody>
+      </p:sp>
+      <p:sp>
+        <p:nvSpPr>
+          <p:cNvPr id="47" name="TextBox 46"/>
           <p:cNvSpPr txBox="1"/>
           <p:nvPr/>
         </p:nvSpPr>
         <p:spPr>
           <a:xfrm>
-            <a:off x="502920" y="4709160"/>
-            <a:ext cx="10972800" cy="457200"/>
+            <a:off x="502920" y="4754880"/>
+            <a:ext cx="11155680" cy="822960"/>
           </a:xfrm>
           <a:prstGeom prst="rect">
             <a:avLst/>
@@ -4553,13 +4092,22 @@
               </a:spcAft>
             </a:pPr>
             <a:r>
+              <a:rPr sz="1600" b="1" i="0">
+                <a:solidFill>
+                  <a:srgbClr val="1F2A44"/>
+                </a:solidFill>
+                <a:latin typeface="Arial"/>
+              </a:rPr>
+              <a:t>Replicável e demoável. </a:t>
+            </a:r>
+            <a:r>
               <a:rPr sz="1600" b="0" i="0">
                 <a:solidFill>
                   <a:srgbClr val="5B6372"/>
                 </a:solidFill>
                 <a:latin typeface="Arial"/>
               </a:rPr>
-              <a:t>O golden path completo, ao vivo: da entrada do projeto à participação segura do cliente.</a:t>
+              <a:t>A seguir: navegação guiada e avaliação da fidelidade da extração do MPO.</a:t>
             </a:r>
           </a:p>
         </p:txBody>
@@ -4573,552 +4121,6 @@
 </file>
 
 <file path=ppt/slides/slide11.xml><?xml version="1.0" encoding="utf-8"?>
-<p:sld xmlns:a="http://schemas.openxmlformats.org/drawingml/2006/main" xmlns:p="http://schemas.openxmlformats.org/presentationml/2006/main" xmlns:r="http://schemas.openxmlformats.org/officeDocument/2006/relationships">
-  <p:cSld>
-    <p:bg>
-      <p:bgPr>
-        <a:solidFill>
-          <a:srgbClr val="FFFFFF"/>
-        </a:solidFill>
-        <a:effectLst/>
-      </p:bgPr>
-    </p:bg>
-    <p:spTree>
-      <p:nvGrpSpPr>
-        <p:cNvPr id="1" name=""/>
-        <p:cNvGrpSpPr/>
-        <p:nvPr/>
-      </p:nvGrpSpPr>
-      <p:grpSpPr/>
-      <p:sp>
-        <p:nvSpPr>
-          <p:cNvPr id="36" name="TextBox 35"/>
-          <p:cNvSpPr txBox="1"/>
-          <p:nvPr/>
-        </p:nvSpPr>
-        <p:spPr>
-          <a:xfrm>
-            <a:off x="457200" y="6492240"/>
-            <a:ext cx="8000000" cy="228600"/>
-          </a:xfrm>
-          <a:prstGeom prst="rect">
-            <a:avLst/>
-          </a:prstGeom>
-          <a:noFill/>
-        </p:spPr>
-        <p:txBody>
-          <a:bodyPr wrap="square" lIns="0" rIns="0" tIns="0" bIns="0" anchor="t">
-            <a:spAutoFit/>
-          </a:bodyPr>
-          <a:lstStyle/>
-          <a:p>
-            <a:pPr algn="l"/>
-            <a:r>
-              <a:rPr sz="900" b="0" i="0">
-                <a:solidFill>
-                  <a:srgbClr val="6B6B7A"/>
-                </a:solidFill>
-                <a:latin typeface="Arial"/>
-              </a:rPr>
-              <a:t>Bruno Rocha · Cynthia Oliveira · Moisés Júnior · Raniel Silva · TAES · UPE/POLI · Julho 2026</a:t>
-            </a:r>
-          </a:p>
-        </p:txBody>
-      </p:sp>
-      <p:sp>
-        <p:nvSpPr>
-          <p:cNvPr id="37" name="TextBox 36"/>
-          <p:cNvSpPr txBox="1"/>
-          <p:nvPr/>
-        </p:nvSpPr>
-        <p:spPr>
-          <a:xfrm>
-            <a:off x="11000000" y="6492240"/>
-            <a:ext cx="1000000" cy="228600"/>
-          </a:xfrm>
-          <a:prstGeom prst="rect">
-            <a:avLst/>
-          </a:prstGeom>
-          <a:noFill/>
-        </p:spPr>
-        <p:txBody>
-          <a:bodyPr wrap="square" lIns="0" rIns="0" tIns="0" bIns="0" anchor="t">
-            <a:spAutoFit/>
-          </a:bodyPr>
-          <a:lstStyle/>
-          <a:p>
-            <a:pPr algn="r"/>
-            <a:r>
-              <a:rPr sz="900" b="0" i="0">
-                <a:solidFill>
-                  <a:srgbClr val="6B6B7A"/>
-                </a:solidFill>
-                <a:latin typeface="Arial"/>
-              </a:rPr>
-              <a:t>11 / 12</a:t>
-            </a:r>
-          </a:p>
-        </p:txBody>
-      </p:sp>
-      <p:pic>
-        <p:nvPicPr>
-          <p:cNvPr id="40" name="Picture 39" descr="image.png"/>
-          <p:cNvPicPr>
-            <a:picLocks noChangeAspect="1"/>
-          </p:cNvPicPr>
-          <p:nvPr/>
-        </p:nvPicPr>
-        <p:blipFill>
-          <a:blip r:embed="rId2"/>
-          <a:stretch>
-            <a:fillRect/>
-          </a:stretch>
-        </p:blipFill>
-        <p:spPr>
-          <a:xfrm>
-            <a:off x="11000000" y="228600"/>
-            <a:ext cx="1066800" cy="801716"/>
-          </a:xfrm>
-          <a:prstGeom prst="rect">
-            <a:avLst/>
-          </a:prstGeom>
-        </p:spPr>
-      </p:pic>
-      <p:sp>
-        <p:nvSpPr>
-          <p:cNvPr id="41" name="TextBox 40"/>
-          <p:cNvSpPr txBox="1"/>
-          <p:nvPr/>
-        </p:nvSpPr>
-        <p:spPr>
-          <a:xfrm>
-            <a:off x="502920" y="457200"/>
-            <a:ext cx="11155680" cy="274320"/>
-          </a:xfrm>
-          <a:prstGeom prst="rect">
-            <a:avLst/>
-          </a:prstGeom>
-          <a:noFill/>
-        </p:spPr>
-        <p:txBody>
-          <a:bodyPr wrap="square" anchor="t">
-            <a:spAutoFit/>
-          </a:bodyPr>
-          <a:lstStyle/>
-          <a:p>
-            <a:pPr algn="l">
-              <a:spcAft>
-                <a:spcPts val="400"/>
-              </a:spcAft>
-            </a:pPr>
-            <a:r>
-              <a:rPr sz="1200" b="1" i="0">
-                <a:solidFill>
-                  <a:srgbClr val="E0261E"/>
-                </a:solidFill>
-                <a:latin typeface="Arial"/>
-              </a:rPr>
-              <a:t>VALOR ENTREGUE</a:t>
-            </a:r>
-          </a:p>
-        </p:txBody>
-      </p:sp>
-      <p:sp>
-        <p:nvSpPr>
-          <p:cNvPr id="42" name="TextBox 41"/>
-          <p:cNvSpPr txBox="1"/>
-          <p:nvPr/>
-        </p:nvSpPr>
-        <p:spPr>
-          <a:xfrm>
-            <a:off x="502920" y="804672"/>
-            <a:ext cx="10241280" cy="914400"/>
-          </a:xfrm>
-          <a:prstGeom prst="rect">
-            <a:avLst/>
-          </a:prstGeom>
-          <a:noFill/>
-        </p:spPr>
-        <p:txBody>
-          <a:bodyPr wrap="square" anchor="t">
-            <a:spAutoFit/>
-          </a:bodyPr>
-          <a:lstStyle/>
-          <a:p>
-            <a:pPr algn="l">
-              <a:spcAft>
-                <a:spcPts val="400"/>
-              </a:spcAft>
-            </a:pPr>
-            <a:r>
-              <a:rPr sz="3000" b="1" i="0">
-                <a:solidFill>
-                  <a:srgbClr val="1F2A44"/>
-                </a:solidFill>
-                <a:latin typeface="Arial"/>
-              </a:rPr>
-              <a:t>A jornada roda de ponta a ponta</a:t>
-            </a:r>
-          </a:p>
-        </p:txBody>
-      </p:sp>
-      <p:sp>
-        <p:nvSpPr>
-          <p:cNvPr id="43" name="Rounded Rectangle 42"/>
-          <p:cNvSpPr/>
-          <p:nvPr/>
-        </p:nvSpPr>
-        <p:spPr>
-          <a:xfrm>
-            <a:off x="502920" y="2788920"/>
-            <a:ext cx="2606040" cy="1371600"/>
-          </a:xfrm>
-          <a:prstGeom prst="roundRect">
-            <a:avLst/>
-          </a:prstGeom>
-          <a:solidFill>
-            <a:srgbClr val="F6F7F9"/>
-          </a:solidFill>
-          <a:ln w="12700">
-            <a:solidFill>
-              <a:srgbClr val="DDE1E7"/>
-            </a:solidFill>
-          </a:ln>
-          <a:effectLst/>
-        </p:spPr>
-        <p:style>
-          <a:lnRef idx="1">
-            <a:schemeClr val="accent1"/>
-          </a:lnRef>
-          <a:fillRef idx="3">
-            <a:schemeClr val="accent1"/>
-          </a:fillRef>
-          <a:effectRef idx="2">
-            <a:schemeClr val="accent1"/>
-          </a:effectRef>
-          <a:fontRef idx="minor">
-            <a:schemeClr val="lt1"/>
-          </a:fontRef>
-        </p:style>
-        <p:txBody>
-          <a:bodyPr rtlCol="0" anchor="ctr" wrap="square" lIns="109728" rIns="109728" tIns="54864" bIns="54864"/>
-          <a:lstStyle/>
-          <a:p>
-            <a:pPr algn="ctr">
-              <a:spcAft>
-                <a:spcPts val="200"/>
-              </a:spcAft>
-            </a:pPr>
-            <a:r>
-              <a:rPr sz="2000" b="1">
-                <a:solidFill>
-                  <a:srgbClr val="2E7D5B"/>
-                </a:solidFill>
-                <a:latin typeface="Arial"/>
-              </a:rPr>
-              <a:t>✓</a:t>
-            </a:r>
-          </a:p>
-          <a:p>
-            <a:pPr algn="ctr">
-              <a:spcAft>
-                <a:spcPts val="200"/>
-              </a:spcAft>
-            </a:pPr>
-            <a:r>
-              <a:rPr sz="1400" b="1">
-                <a:solidFill>
-                  <a:srgbClr val="1F2A44"/>
-                </a:solidFill>
-                <a:latin typeface="Arial"/>
-              </a:rPr>
-              <a:t>Isolamento do cliente</a:t>
-            </a:r>
-          </a:p>
-        </p:txBody>
-      </p:sp>
-      <p:sp>
-        <p:nvSpPr>
-          <p:cNvPr id="44" name="Rounded Rectangle 43"/>
-          <p:cNvSpPr/>
-          <p:nvPr/>
-        </p:nvSpPr>
-        <p:spPr>
-          <a:xfrm>
-            <a:off x="3310128" y="2788920"/>
-            <a:ext cx="2606040" cy="1371600"/>
-          </a:xfrm>
-          <a:prstGeom prst="roundRect">
-            <a:avLst/>
-          </a:prstGeom>
-          <a:solidFill>
-            <a:srgbClr val="F6F7F9"/>
-          </a:solidFill>
-          <a:ln w="12700">
-            <a:solidFill>
-              <a:srgbClr val="DDE1E7"/>
-            </a:solidFill>
-          </a:ln>
-          <a:effectLst/>
-        </p:spPr>
-        <p:style>
-          <a:lnRef idx="1">
-            <a:schemeClr val="accent1"/>
-          </a:lnRef>
-          <a:fillRef idx="3">
-            <a:schemeClr val="accent1"/>
-          </a:fillRef>
-          <a:effectRef idx="2">
-            <a:schemeClr val="accent1"/>
-          </a:effectRef>
-          <a:fontRef idx="minor">
-            <a:schemeClr val="lt1"/>
-          </a:fontRef>
-        </p:style>
-        <p:txBody>
-          <a:bodyPr rtlCol="0" anchor="ctr" wrap="square" lIns="109728" rIns="109728" tIns="54864" bIns="54864"/>
-          <a:lstStyle/>
-          <a:p>
-            <a:pPr algn="ctr">
-              <a:spcAft>
-                <a:spcPts val="200"/>
-              </a:spcAft>
-            </a:pPr>
-            <a:r>
-              <a:rPr sz="2000" b="1">
-                <a:solidFill>
-                  <a:srgbClr val="2E7D5B"/>
-                </a:solidFill>
-                <a:latin typeface="Arial"/>
-              </a:rPr>
-              <a:t>✓</a:t>
-            </a:r>
-          </a:p>
-          <a:p>
-            <a:pPr algn="ctr">
-              <a:spcAft>
-                <a:spcPts val="200"/>
-              </a:spcAft>
-            </a:pPr>
-            <a:r>
-              <a:rPr sz="1400" b="1">
-                <a:solidFill>
-                  <a:srgbClr val="1F2A44"/>
-                </a:solidFill>
-                <a:latin typeface="Arial"/>
-              </a:rPr>
-              <a:t>Reaproveitamento</a:t>
-            </a:r>
-          </a:p>
-        </p:txBody>
-      </p:sp>
-      <p:sp>
-        <p:nvSpPr>
-          <p:cNvPr id="45" name="Rounded Rectangle 44"/>
-          <p:cNvSpPr/>
-          <p:nvPr/>
-        </p:nvSpPr>
-        <p:spPr>
-          <a:xfrm>
-            <a:off x="6117336" y="2788920"/>
-            <a:ext cx="2606040" cy="1371600"/>
-          </a:xfrm>
-          <a:prstGeom prst="roundRect">
-            <a:avLst/>
-          </a:prstGeom>
-          <a:solidFill>
-            <a:srgbClr val="F6F7F9"/>
-          </a:solidFill>
-          <a:ln w="12700">
-            <a:solidFill>
-              <a:srgbClr val="DDE1E7"/>
-            </a:solidFill>
-          </a:ln>
-          <a:effectLst/>
-        </p:spPr>
-        <p:style>
-          <a:lnRef idx="1">
-            <a:schemeClr val="accent1"/>
-          </a:lnRef>
-          <a:fillRef idx="3">
-            <a:schemeClr val="accent1"/>
-          </a:fillRef>
-          <a:effectRef idx="2">
-            <a:schemeClr val="accent1"/>
-          </a:effectRef>
-          <a:fontRef idx="minor">
-            <a:schemeClr val="lt1"/>
-          </a:fontRef>
-        </p:style>
-        <p:txBody>
-          <a:bodyPr rtlCol="0" anchor="ctr" wrap="square" lIns="109728" rIns="109728" tIns="54864" bIns="54864"/>
-          <a:lstStyle/>
-          <a:p>
-            <a:pPr algn="ctr">
-              <a:spcAft>
-                <a:spcPts val="200"/>
-              </a:spcAft>
-            </a:pPr>
-            <a:r>
-              <a:rPr sz="2000" b="1">
-                <a:solidFill>
-                  <a:srgbClr val="2E7D5B"/>
-                </a:solidFill>
-                <a:latin typeface="Arial"/>
-              </a:rPr>
-              <a:t>✓</a:t>
-            </a:r>
-          </a:p>
-          <a:p>
-            <a:pPr algn="ctr">
-              <a:spcAft>
-                <a:spcPts val="200"/>
-              </a:spcAft>
-            </a:pPr>
-            <a:r>
-              <a:rPr sz="1400" b="1">
-                <a:solidFill>
-                  <a:srgbClr val="1F2A44"/>
-                </a:solidFill>
-                <a:latin typeface="Arial"/>
-              </a:rPr>
-              <a:t>Engajamento</a:t>
-            </a:r>
-          </a:p>
-        </p:txBody>
-      </p:sp>
-      <p:sp>
-        <p:nvSpPr>
-          <p:cNvPr id="46" name="Rounded Rectangle 45"/>
-          <p:cNvSpPr/>
-          <p:nvPr/>
-        </p:nvSpPr>
-        <p:spPr>
-          <a:xfrm>
-            <a:off x="8924544" y="2788920"/>
-            <a:ext cx="2606040" cy="1371600"/>
-          </a:xfrm>
-          <a:prstGeom prst="roundRect">
-            <a:avLst/>
-          </a:prstGeom>
-          <a:solidFill>
-            <a:srgbClr val="F6F7F9"/>
-          </a:solidFill>
-          <a:ln w="12700">
-            <a:solidFill>
-              <a:srgbClr val="DDE1E7"/>
-            </a:solidFill>
-          </a:ln>
-          <a:effectLst/>
-        </p:spPr>
-        <p:style>
-          <a:lnRef idx="1">
-            <a:schemeClr val="accent1"/>
-          </a:lnRef>
-          <a:fillRef idx="3">
-            <a:schemeClr val="accent1"/>
-          </a:fillRef>
-          <a:effectRef idx="2">
-            <a:schemeClr val="accent1"/>
-          </a:effectRef>
-          <a:fontRef idx="minor">
-            <a:schemeClr val="lt1"/>
-          </a:fontRef>
-        </p:style>
-        <p:txBody>
-          <a:bodyPr rtlCol="0" anchor="ctr" wrap="square" lIns="109728" rIns="109728" tIns="54864" bIns="54864"/>
-          <a:lstStyle/>
-          <a:p>
-            <a:pPr algn="ctr">
-              <a:spcAft>
-                <a:spcPts val="200"/>
-              </a:spcAft>
-            </a:pPr>
-            <a:r>
-              <a:rPr sz="2000" b="1">
-                <a:solidFill>
-                  <a:srgbClr val="2E7D5B"/>
-                </a:solidFill>
-                <a:latin typeface="Arial"/>
-              </a:rPr>
-              <a:t>✓</a:t>
-            </a:r>
-          </a:p>
-          <a:p>
-            <a:pPr algn="ctr">
-              <a:spcAft>
-                <a:spcPts val="200"/>
-              </a:spcAft>
-            </a:pPr>
-            <a:r>
-              <a:rPr sz="1400" b="1">
-                <a:solidFill>
-                  <a:srgbClr val="1F2A44"/>
-                </a:solidFill>
-                <a:latin typeface="Arial"/>
-              </a:rPr>
-              <a:t>IA copiloto</a:t>
-            </a:r>
-          </a:p>
-        </p:txBody>
-      </p:sp>
-      <p:sp>
-        <p:nvSpPr>
-          <p:cNvPr id="47" name="TextBox 46"/>
-          <p:cNvSpPr txBox="1"/>
-          <p:nvPr/>
-        </p:nvSpPr>
-        <p:spPr>
-          <a:xfrm>
-            <a:off x="502920" y="4754880"/>
-            <a:ext cx="10972800" cy="822960"/>
-          </a:xfrm>
-          <a:prstGeom prst="rect">
-            <a:avLst/>
-          </a:prstGeom>
-          <a:noFill/>
-        </p:spPr>
-        <p:txBody>
-          <a:bodyPr wrap="square" anchor="t">
-            <a:spAutoFit/>
-          </a:bodyPr>
-          <a:lstStyle/>
-          <a:p>
-            <a:pPr algn="l">
-              <a:spcAft>
-                <a:spcPts val="400"/>
-              </a:spcAft>
-            </a:pPr>
-            <a:r>
-              <a:rPr sz="1600" b="1" i="0">
-                <a:solidFill>
-                  <a:srgbClr val="1F2A44"/>
-                </a:solidFill>
-                <a:latin typeface="Arial"/>
-              </a:rPr>
-              <a:t>Replicável e demoável. </a:t>
-            </a:r>
-            <a:r>
-              <a:rPr sz="1600" b="0" i="0">
-                <a:solidFill>
-                  <a:srgbClr val="5B6372"/>
-                </a:solidFill>
-                <a:latin typeface="Arial"/>
-              </a:rPr>
-              <a:t>A seguir: navegação guiada e avaliação da fidelidade da extração do MPO.</a:t>
-            </a:r>
-          </a:p>
-        </p:txBody>
-      </p:sp>
-    </p:spTree>
-  </p:cSld>
-  <p:clrMapOvr>
-    <a:masterClrMapping/>
-  </p:clrMapOvr>
-</p:sld>
-</file>
-
-<file path=ppt/slides/slide12.xml><?xml version="1.0" encoding="utf-8"?>
 <p:sld xmlns:a="http://schemas.openxmlformats.org/drawingml/2006/main" xmlns:p="http://schemas.openxmlformats.org/presentationml/2006/main" xmlns:r="http://schemas.openxmlformats.org/officeDocument/2006/relationships">
   <p:cSld>
     <p:bg>
@@ -5805,7 +4807,7 @@
                 </a:solidFill>
                 <a:latin typeface="Arial"/>
               </a:rPr>
-              <a:t>A jornada de valor</a:t>
+              <a:t>A camada de IA</a:t>
             </a:r>
           </a:p>
         </p:txBody>
@@ -5840,7 +4842,7 @@
                 </a:solidFill>
                 <a:latin typeface="Arial"/>
               </a:rPr>
-              <a:t>O ciclo funcionando</a:t>
+              <a:t>IA assistiva, com revisão humana</a:t>
             </a:r>
           </a:p>
         </p:txBody>
@@ -5953,7 +4955,7 @@
                 </a:solidFill>
                 <a:latin typeface="Arial"/>
               </a:rPr>
-              <a:t>Diferencial e IA</a:t>
+              <a:t>Diferencial e reaproveitamento</a:t>
             </a:r>
           </a:p>
         </p:txBody>
@@ -5988,7 +4990,7 @@
                 </a:solidFill>
                 <a:latin typeface="Arial"/>
               </a:rPr>
-              <a:t>Cliente dentro, IA copiloto</a:t>
+              <a:t>Cliente com muralha e reuso</a:t>
             </a:r>
           </a:p>
         </p:txBody>
@@ -6101,7 +5103,7 @@
                 </a:solidFill>
                 <a:latin typeface="Arial"/>
               </a:rPr>
-              <a:t>Validação e valor</a:t>
+              <a:t>Experimento e valor</a:t>
             </a:r>
           </a:p>
         </p:txBody>
@@ -6136,7 +5138,7 @@
                 </a:solidFill>
                 <a:latin typeface="Arial"/>
               </a:rPr>
-              <a:t>Evidência e entrega</a:t>
+              <a:t>Método, resultados e entrega</a:t>
             </a:r>
           </a:p>
         </p:txBody>
@@ -6335,7 +5337,7 @@
                 </a:solidFill>
                 <a:latin typeface="Arial"/>
               </a:rPr>
-              <a:t>2 / 12</a:t>
+              <a:t>2 / 11</a:t>
             </a:r>
           </a:p>
         </p:txBody>
@@ -6455,7 +5457,7 @@
                 </a:solidFill>
                 <a:latin typeface="Arial"/>
               </a:rPr>
-              <a:t>3 / 12</a:t>
+              <a:t>3 / 11</a:t>
             </a:r>
           </a:p>
         </p:txBody>
@@ -6508,7 +5510,7 @@
         <p:spPr>
           <a:xfrm>
             <a:off x="502920" y="804672"/>
-            <a:ext cx="10241280" cy="914400"/>
+            <a:ext cx="11155680" cy="914400"/>
           </a:xfrm>
           <a:prstGeom prst="rect">
             <a:avLst/>
@@ -6546,8 +5548,8 @@
         </p:nvSpPr>
         <p:spPr>
           <a:xfrm>
-            <a:off x="502920" y="1783080"/>
-            <a:ext cx="10972800" cy="365760"/>
+            <a:off x="502920" y="1737360"/>
+            <a:ext cx="11155680" cy="365760"/>
           </a:xfrm>
           <a:prstGeom prst="rect">
             <a:avLst/>
@@ -6566,7 +5568,7 @@
               </a:spcAft>
             </a:pPr>
             <a:r>
-              <a:rPr sz="1600" b="0" i="0">
+              <a:rPr sz="1550" b="0" i="0">
                 <a:solidFill>
                   <a:srgbClr val="5B6372"/>
                 </a:solidFill>
@@ -6616,12 +5618,12 @@
           </a:fontRef>
         </p:style>
         <p:txBody>
-          <a:bodyPr rtlCol="0" anchor="ctr" wrap="square" lIns="109728" rIns="109728" tIns="54864" bIns="54864"/>
+          <a:bodyPr rtlCol="0" anchor="ctr" wrap="square" lIns="128016" rIns="128016" tIns="54864" bIns="54864"/>
           <a:lstStyle/>
           <a:p>
             <a:pPr algn="ctr">
               <a:spcAft>
-                <a:spcPts val="200"/>
+                <a:spcPts val="300"/>
               </a:spcAft>
             </a:pPr>
             <a:r>
@@ -6637,7 +5639,7 @@
           <a:p>
             <a:pPr algn="ctr">
               <a:spcAft>
-                <a:spcPts val="200"/>
+                <a:spcPts val="300"/>
               </a:spcAft>
             </a:pPr>
             <a:r>
@@ -6691,12 +5693,12 @@
           </a:fontRef>
         </p:style>
         <p:txBody>
-          <a:bodyPr rtlCol="0" anchor="ctr" wrap="square" lIns="109728" rIns="109728" tIns="54864" bIns="54864"/>
+          <a:bodyPr rtlCol="0" anchor="ctr" wrap="square" lIns="128016" rIns="128016" tIns="54864" bIns="54864"/>
           <a:lstStyle/>
           <a:p>
             <a:pPr algn="ctr">
               <a:spcAft>
-                <a:spcPts val="200"/>
+                <a:spcPts val="300"/>
               </a:spcAft>
             </a:pPr>
             <a:r>
@@ -6706,13 +5708,13 @@
                 </a:solidFill>
                 <a:latin typeface="Arial"/>
               </a:rPr>
-              <a:t>O sênior vira gargalo</a:t>
+              <a:t>Depende sempre dos mesmos</a:t>
             </a:r>
           </a:p>
           <a:p>
             <a:pPr algn="ctr">
               <a:spcAft>
-                <a:spcPts val="200"/>
+                <a:spcPts val="300"/>
               </a:spcAft>
             </a:pPr>
             <a:r>
@@ -6722,7 +5724,7 @@
                 </a:solidFill>
                 <a:latin typeface="Arial"/>
               </a:rPr>
-              <a:t>Só ele conecta os pontos entre projetos</a:t>
+              <a:t>Só quem tem estrada liga os pontos entre projetos</a:t>
             </a:r>
           </a:p>
         </p:txBody>
@@ -6766,12 +5768,12 @@
           </a:fontRef>
         </p:style>
         <p:txBody>
-          <a:bodyPr rtlCol="0" anchor="ctr" wrap="square" lIns="109728" rIns="109728" tIns="54864" bIns="54864"/>
+          <a:bodyPr rtlCol="0" anchor="ctr" wrap="square" lIns="128016" rIns="128016" tIns="54864" bIns="54864"/>
           <a:lstStyle/>
           <a:p>
             <a:pPr algn="ctr">
               <a:spcAft>
-                <a:spcPts val="200"/>
+                <a:spcPts val="300"/>
               </a:spcAft>
             </a:pPr>
             <a:r>
@@ -6787,7 +5789,7 @@
           <a:p>
             <a:pPr algn="ctr">
               <a:spcAft>
-                <a:spcPts val="200"/>
+                <a:spcPts val="300"/>
               </a:spcAft>
             </a:pPr>
             <a:r>
@@ -6917,7 +5919,7 @@
                 </a:solidFill>
                 <a:latin typeface="Arial"/>
               </a:rPr>
-              <a:t>4 / 12</a:t>
+              <a:t>4 / 11</a:t>
             </a:r>
           </a:p>
         </p:txBody>
@@ -6970,7 +5972,7 @@
         <p:spPr>
           <a:xfrm>
             <a:off x="502920" y="804672"/>
-            <a:ext cx="10241280" cy="914400"/>
+            <a:ext cx="11155680" cy="914400"/>
           </a:xfrm>
           <a:prstGeom prst="rect">
             <a:avLst/>
@@ -7008,8 +6010,8 @@
         </p:nvSpPr>
         <p:spPr>
           <a:xfrm>
-            <a:off x="502920" y="1783080"/>
-            <a:ext cx="10972800" cy="365760"/>
+            <a:off x="502920" y="1737360"/>
+            <a:ext cx="11155680" cy="365760"/>
           </a:xfrm>
           <a:prstGeom prst="rect">
             <a:avLst/>
@@ -7028,7 +6030,7 @@
               </a:spcAft>
             </a:pPr>
             <a:r>
-              <a:rPr sz="1600" b="0" i="0">
+              <a:rPr sz="1550" b="0" i="0">
                 <a:solidFill>
                   <a:srgbClr val="5B6372"/>
                 </a:solidFill>
@@ -7076,12 +6078,12 @@
           </a:fontRef>
         </p:style>
         <p:txBody>
-          <a:bodyPr rtlCol="0" anchor="ctr" wrap="square" lIns="109728" rIns="109728" tIns="54864" bIns="54864"/>
+          <a:bodyPr rtlCol="0" anchor="ctr" wrap="square" lIns="128016" rIns="128016" tIns="54864" bIns="54864"/>
           <a:lstStyle/>
           <a:p>
             <a:pPr algn="ctr">
               <a:spcAft>
-                <a:spcPts val="200"/>
+                <a:spcPts val="300"/>
               </a:spcAft>
             </a:pPr>
             <a:r>
@@ -7177,12 +6179,12 @@
           </a:fontRef>
         </p:style>
         <p:txBody>
-          <a:bodyPr rtlCol="0" anchor="ctr" wrap="square" lIns="109728" rIns="109728" tIns="54864" bIns="54864"/>
+          <a:bodyPr rtlCol="0" anchor="ctr" wrap="square" lIns="128016" rIns="128016" tIns="54864" bIns="54864"/>
           <a:lstStyle/>
           <a:p>
             <a:pPr algn="ctr">
               <a:spcAft>
-                <a:spcPts val="200"/>
+                <a:spcPts val="300"/>
               </a:spcAft>
             </a:pPr>
             <a:r>
@@ -7278,12 +6280,12 @@
           </a:fontRef>
         </p:style>
         <p:txBody>
-          <a:bodyPr rtlCol="0" anchor="ctr" wrap="square" lIns="109728" rIns="109728" tIns="54864" bIns="54864"/>
+          <a:bodyPr rtlCol="0" anchor="ctr" wrap="square" lIns="128016" rIns="128016" tIns="54864" bIns="54864"/>
           <a:lstStyle/>
           <a:p>
             <a:pPr algn="ctr">
               <a:spcAft>
-                <a:spcPts val="200"/>
+                <a:spcPts val="300"/>
               </a:spcAft>
             </a:pPr>
             <a:r>
@@ -7337,12 +6339,12 @@
           </a:fontRef>
         </p:style>
         <p:txBody>
-          <a:bodyPr rtlCol="0" anchor="ctr" wrap="square" lIns="109728" rIns="109728" tIns="54864" bIns="54864"/>
+          <a:bodyPr rtlCol="0" anchor="ctr" wrap="square" lIns="128016" rIns="128016" tIns="54864" bIns="54864"/>
           <a:lstStyle/>
           <a:p>
             <a:pPr algn="ctr">
               <a:spcAft>
-                <a:spcPts val="200"/>
+                <a:spcPts val="300"/>
               </a:spcAft>
             </a:pPr>
             <a:r>
@@ -7472,7 +6474,7 @@
                 </a:solidFill>
                 <a:latin typeface="Arial"/>
               </a:rPr>
-              <a:t>5 / 12</a:t>
+              <a:t>5 / 11</a:t>
             </a:r>
           </a:p>
         </p:txBody>
@@ -7511,7 +6513,7 @@
                 </a:solidFill>
                 <a:latin typeface="Arial"/>
               </a:rPr>
-              <a:t>A JORNADA</a:t>
+              <a:t>A CAMADA DE IA</a:t>
             </a:r>
           </a:p>
         </p:txBody>
@@ -7525,7 +6527,7 @@
         <p:spPr>
           <a:xfrm>
             <a:off x="502920" y="804672"/>
-            <a:ext cx="10241280" cy="914400"/>
+            <a:ext cx="11155680" cy="914400"/>
           </a:xfrm>
           <a:prstGeom prst="rect">
             <a:avLst/>
@@ -7550,30 +6552,71 @@
                 </a:solidFill>
                 <a:latin typeface="Arial"/>
               </a:rPr>
-              <a:t>Do cadastro ao aprendizado, com a IA acelerando</a:t>
-            </a:r>
-          </a:p>
-        </p:txBody>
-      </p:sp>
-      <p:sp>
-        <p:nvSpPr>
-          <p:cNvPr id="128" name="Rounded Rectangle 127"/>
+              <a:t>Assistiva, ancorada e auditável</a:t>
+            </a:r>
+          </a:p>
+        </p:txBody>
+      </p:sp>
+      <p:sp>
+        <p:nvSpPr>
+          <p:cNvPr id="128" name="TextBox 127"/>
+          <p:cNvSpPr txBox="1"/>
+          <p:nvPr/>
+        </p:nvSpPr>
+        <p:spPr>
+          <a:xfrm>
+            <a:off x="502920" y="1737360"/>
+            <a:ext cx="11155680" cy="365760"/>
+          </a:xfrm>
+          <a:prstGeom prst="rect">
+            <a:avLst/>
+          </a:prstGeom>
+          <a:noFill/>
+        </p:spPr>
+        <p:txBody>
+          <a:bodyPr wrap="square" anchor="t">
+            <a:spAutoFit/>
+          </a:bodyPr>
+          <a:lstStyle/>
+          <a:p>
+            <a:pPr algn="l">
+              <a:spcAft>
+                <a:spcPts val="400"/>
+              </a:spcAft>
+            </a:pPr>
+            <a:r>
+              <a:rPr sz="1550" b="0" i="0">
+                <a:solidFill>
+                  <a:srgbClr val="5B6372"/>
+                </a:solidFill>
+                <a:latin typeface="Arial"/>
+              </a:rPr>
+              <a:t>A IA acelera cada ponta do ciclo, sempre com o consultor no comando.</a:t>
+            </a:r>
+          </a:p>
+        </p:txBody>
+      </p:sp>
+      <p:sp>
+        <p:nvSpPr>
+          <p:cNvPr id="129" name="Rounded Rectangle 128"/>
           <p:cNvSpPr/>
           <p:nvPr/>
         </p:nvSpPr>
         <p:spPr>
           <a:xfrm>
-            <a:off x="502920" y="2926080"/>
-            <a:ext cx="1965960" cy="1051560"/>
+            <a:off x="502920" y="2286000"/>
+            <a:ext cx="5394960" cy="3703320"/>
           </a:xfrm>
           <a:prstGeom prst="roundRect">
             <a:avLst/>
           </a:prstGeom>
           <a:solidFill>
-            <a:srgbClr val="E0261E"/>
+            <a:srgbClr val="F6F7F9"/>
           </a:solidFill>
-          <a:ln>
-            <a:noFill/>
+          <a:ln w="12700">
+            <a:solidFill>
+              <a:srgbClr val="DDE1E7"/>
+            </a:solidFill>
           </a:ln>
           <a:effectLst/>
         </p:spPr>
@@ -7592,61 +6635,213 @@
           </a:fontRef>
         </p:style>
         <p:txBody>
-          <a:bodyPr rtlCol="0" anchor="ctr" wrap="square" lIns="109728" rIns="109728" tIns="54864" bIns="54864"/>
-          <a:lstStyle/>
-          <a:p>
-            <a:pPr algn="ctr">
+          <a:bodyPr rtlCol="0" anchor="ctr"/>
+          <a:lstStyle/>
+          <a:p>
+            <a:pPr algn="ctr"/>
+          </a:p>
+        </p:txBody>
+      </p:sp>
+      <p:sp>
+        <p:nvSpPr>
+          <p:cNvPr id="130" name="TextBox 129"/>
+          <p:cNvSpPr txBox="1"/>
+          <p:nvPr/>
+        </p:nvSpPr>
+        <p:spPr>
+          <a:xfrm>
+            <a:off x="731520" y="2487168"/>
+            <a:ext cx="4937760" cy="3337560"/>
+          </a:xfrm>
+          <a:prstGeom prst="rect">
+            <a:avLst/>
+          </a:prstGeom>
+          <a:noFill/>
+        </p:spPr>
+        <p:txBody>
+          <a:bodyPr wrap="square">
+            <a:spAutoFit/>
+          </a:bodyPr>
+          <a:lstStyle/>
+          <a:p>
+            <a:pPr>
               <a:spcAft>
-                <a:spcPts val="200"/>
+                <a:spcPts val="1000"/>
               </a:spcAft>
             </a:pPr>
             <a:r>
-              <a:rPr sz="1500" b="1">
-                <a:solidFill>
-                  <a:srgbClr val="FFFFFF"/>
-                </a:solidFill>
-                <a:latin typeface="Arial"/>
-              </a:rPr>
-              <a:t>Cadastro</a:t>
-            </a:r>
-          </a:p>
-          <a:p>
-            <a:pPr algn="ctr">
+              <a:rPr sz="1200" b="1">
+                <a:solidFill>
+                  <a:srgbClr val="E0261E"/>
+                </a:solidFill>
+                <a:latin typeface="Arial"/>
+              </a:rPr>
+              <a:t>PAPÉIS DA IA NO CICLO</a:t>
+            </a:r>
+          </a:p>
+          <a:p>
+            <a:pPr>
+              <a:spcBef>
+                <a:spcPts val="600"/>
+              </a:spcBef>
               <a:spcAft>
-                <a:spcPts val="200"/>
+                <a:spcPts val="100"/>
               </a:spcAft>
             </a:pPr>
             <a:r>
-              <a:rPr sz="1100" b="0">
-                <a:solidFill>
-                  <a:srgbClr val="FFFFFF"/>
-                </a:solidFill>
-                <a:latin typeface="Arial"/>
-              </a:rPr>
-              <a:t>com IA</a:t>
-            </a:r>
-          </a:p>
-        </p:txBody>
-      </p:sp>
-      <p:sp>
-        <p:nvSpPr>
-          <p:cNvPr id="129" name="Chevron 128"/>
+              <a:rPr sz="1450" b="1">
+                <a:solidFill>
+                  <a:srgbClr val="1F2A44"/>
+                </a:solidFill>
+                <a:latin typeface="Arial"/>
+              </a:rPr>
+              <a:t>Configuradora</a:t>
+            </a:r>
+          </a:p>
+          <a:p>
+            <a:pPr>
+              <a:spcAft>
+                <a:spcPts val="400"/>
+              </a:spcAft>
+            </a:pPr>
+            <a:r>
+              <a:rPr sz="1250">
+                <a:solidFill>
+                  <a:srgbClr val="5B6372"/>
+                </a:solidFill>
+                <a:latin typeface="Arial"/>
+              </a:rPr>
+              <a:t>No cadastro: propõe o domínio e o que acompanhar</a:t>
+            </a:r>
+          </a:p>
+          <a:p>
+            <a:pPr>
+              <a:spcBef>
+                <a:spcPts val="600"/>
+              </a:spcBef>
+              <a:spcAft>
+                <a:spcPts val="100"/>
+              </a:spcAft>
+            </a:pPr>
+            <a:r>
+              <a:rPr sz="1450" b="1">
+                <a:solidFill>
+                  <a:srgbClr val="1F2A44"/>
+                </a:solidFill>
+                <a:latin typeface="Arial"/>
+              </a:rPr>
+              <a:t>Observadora</a:t>
+            </a:r>
+          </a:p>
+          <a:p>
+            <a:pPr>
+              <a:spcAft>
+                <a:spcPts val="400"/>
+              </a:spcAft>
+            </a:pPr>
+            <a:r>
+              <a:rPr sz="1250">
+                <a:solidFill>
+                  <a:srgbClr val="5B6372"/>
+                </a:solidFill>
+                <a:latin typeface="Arial"/>
+              </a:rPr>
+              <a:t>Sugere observações à luz do MPO</a:t>
+            </a:r>
+          </a:p>
+          <a:p>
+            <a:pPr>
+              <a:spcBef>
+                <a:spcPts val="600"/>
+              </a:spcBef>
+              <a:spcAft>
+                <a:spcPts val="100"/>
+              </a:spcAft>
+            </a:pPr>
+            <a:r>
+              <a:rPr sz="1450" b="1">
+                <a:solidFill>
+                  <a:srgbClr val="1F2A44"/>
+                </a:solidFill>
+                <a:latin typeface="Arial"/>
+              </a:rPr>
+              <a:t>Sintetizadora</a:t>
+            </a:r>
+          </a:p>
+          <a:p>
+            <a:pPr>
+              <a:spcAft>
+                <a:spcPts val="400"/>
+              </a:spcAft>
+            </a:pPr>
+            <a:r>
+              <a:rPr sz="1250">
+                <a:solidFill>
+                  <a:srgbClr val="5B6372"/>
+                </a:solidFill>
+                <a:latin typeface="Arial"/>
+              </a:rPr>
+              <a:t>Consolida o aprendizado da conversa</a:t>
+            </a:r>
+          </a:p>
+          <a:p>
+            <a:pPr>
+              <a:spcBef>
+                <a:spcPts val="600"/>
+              </a:spcBef>
+              <a:spcAft>
+                <a:spcPts val="100"/>
+              </a:spcAft>
+            </a:pPr>
+            <a:r>
+              <a:rPr sz="1450" b="1">
+                <a:solidFill>
+                  <a:srgbClr val="1F2A44"/>
+                </a:solidFill>
+                <a:latin typeface="Arial"/>
+              </a:rPr>
+              <a:t>Conectora</a:t>
+            </a:r>
+          </a:p>
+          <a:p>
+            <a:pPr>
+              <a:spcAft>
+                <a:spcPts val="400"/>
+              </a:spcAft>
+            </a:pPr>
+            <a:r>
+              <a:rPr sz="1250">
+                <a:solidFill>
+                  <a:srgbClr val="5B6372"/>
+                </a:solidFill>
+                <a:latin typeface="Arial"/>
+              </a:rPr>
+              <a:t>Sintetiza padrões entre projetos do domínio</a:t>
+            </a:r>
+          </a:p>
+        </p:txBody>
+      </p:sp>
+      <p:sp>
+        <p:nvSpPr>
+          <p:cNvPr id="131" name="Rounded Rectangle 130"/>
           <p:cNvSpPr/>
           <p:nvPr/>
         </p:nvSpPr>
         <p:spPr>
           <a:xfrm>
-            <a:off x="2487168" y="3291840"/>
-            <a:ext cx="365760" cy="320040"/>
-          </a:xfrm>
-          <a:prstGeom prst="chevron">
+            <a:off x="6309360" y="2286000"/>
+            <a:ext cx="5394960" cy="3703320"/>
+          </a:xfrm>
+          <a:prstGeom prst="roundRect">
             <a:avLst/>
           </a:prstGeom>
           <a:solidFill>
-            <a:srgbClr val="8A909C"/>
+            <a:srgbClr val="F6F7F9"/>
           </a:solidFill>
-          <a:ln>
-            <a:noFill/>
+          <a:ln w="12700">
+            <a:solidFill>
+              <a:srgbClr val="DDE1E7"/>
+            </a:solidFill>
           </a:ln>
           <a:effectLst/>
         </p:spPr>
@@ -7674,415 +6869,144 @@
       </p:sp>
       <p:sp>
         <p:nvSpPr>
-          <p:cNvPr id="130" name="Rounded Rectangle 129"/>
-          <p:cNvSpPr/>
-          <p:nvPr/>
-        </p:nvSpPr>
-        <p:spPr>
-          <a:xfrm>
-            <a:off x="2761488" y="2926080"/>
-            <a:ext cx="1965960" cy="1051560"/>
-          </a:xfrm>
-          <a:prstGeom prst="roundRect">
-            <a:avLst/>
-          </a:prstGeom>
-          <a:solidFill>
-            <a:srgbClr val="1F2A44"/>
-          </a:solidFill>
-          <a:ln>
-            <a:noFill/>
-          </a:ln>
-          <a:effectLst/>
-        </p:spPr>
-        <p:style>
-          <a:lnRef idx="1">
-            <a:schemeClr val="accent1"/>
-          </a:lnRef>
-          <a:fillRef idx="3">
-            <a:schemeClr val="accent1"/>
-          </a:fillRef>
-          <a:effectRef idx="2">
-            <a:schemeClr val="accent1"/>
-          </a:effectRef>
-          <a:fontRef idx="minor">
-            <a:schemeClr val="lt1"/>
-          </a:fontRef>
-        </p:style>
-        <p:txBody>
-          <a:bodyPr rtlCol="0" anchor="ctr" wrap="square" lIns="109728" rIns="109728" tIns="54864" bIns="54864"/>
-          <a:lstStyle/>
-          <a:p>
-            <a:pPr algn="ctr">
+          <p:cNvPr id="132" name="TextBox 131"/>
+          <p:cNvSpPr txBox="1"/>
+          <p:nvPr/>
+        </p:nvSpPr>
+        <p:spPr>
+          <a:xfrm>
+            <a:off x="6537960" y="2487168"/>
+            <a:ext cx="4937760" cy="3337560"/>
+          </a:xfrm>
+          <a:prstGeom prst="rect">
+            <a:avLst/>
+          </a:prstGeom>
+          <a:noFill/>
+        </p:spPr>
+        <p:txBody>
+          <a:bodyPr wrap="square">
+            <a:spAutoFit/>
+          </a:bodyPr>
+          <a:lstStyle/>
+          <a:p>
+            <a:pPr>
               <a:spcAft>
-                <a:spcPts val="200"/>
+                <a:spcPts val="1000"/>
               </a:spcAft>
             </a:pPr>
             <a:r>
-              <a:rPr sz="1500" b="1">
-                <a:solidFill>
-                  <a:srgbClr val="FFFFFF"/>
-                </a:solidFill>
-                <a:latin typeface="Arial"/>
-              </a:rPr>
-              <a:t>Observação</a:t>
-            </a:r>
-          </a:p>
-        </p:txBody>
-      </p:sp>
-      <p:sp>
-        <p:nvSpPr>
-          <p:cNvPr id="131" name="Chevron 130"/>
-          <p:cNvSpPr/>
-          <p:nvPr/>
-        </p:nvSpPr>
-        <p:spPr>
-          <a:xfrm>
-            <a:off x="4745736" y="3291840"/>
-            <a:ext cx="365760" cy="320040"/>
-          </a:xfrm>
-          <a:prstGeom prst="chevron">
-            <a:avLst/>
-          </a:prstGeom>
-          <a:solidFill>
-            <a:srgbClr val="8A909C"/>
-          </a:solidFill>
-          <a:ln>
-            <a:noFill/>
-          </a:ln>
-          <a:effectLst/>
-        </p:spPr>
-        <p:style>
-          <a:lnRef idx="1">
-            <a:schemeClr val="accent1"/>
-          </a:lnRef>
-          <a:fillRef idx="3">
-            <a:schemeClr val="accent1"/>
-          </a:fillRef>
-          <a:effectRef idx="2">
-            <a:schemeClr val="accent1"/>
-          </a:effectRef>
-          <a:fontRef idx="minor">
-            <a:schemeClr val="lt1"/>
-          </a:fontRef>
-        </p:style>
-        <p:txBody>
-          <a:bodyPr rtlCol="0" anchor="ctr"/>
-          <a:lstStyle/>
-          <a:p>
-            <a:pPr algn="ctr"/>
-          </a:p>
-        </p:txBody>
-      </p:sp>
-      <p:sp>
-        <p:nvSpPr>
-          <p:cNvPr id="132" name="Rounded Rectangle 131"/>
-          <p:cNvSpPr/>
-          <p:nvPr/>
-        </p:nvSpPr>
-        <p:spPr>
-          <a:xfrm>
-            <a:off x="5020056" y="2926080"/>
-            <a:ext cx="1965960" cy="1051560"/>
-          </a:xfrm>
-          <a:prstGeom prst="roundRect">
-            <a:avLst/>
-          </a:prstGeom>
-          <a:solidFill>
-            <a:srgbClr val="1F2A44"/>
-          </a:solidFill>
-          <a:ln>
-            <a:noFill/>
-          </a:ln>
-          <a:effectLst/>
-        </p:spPr>
-        <p:style>
-          <a:lnRef idx="1">
-            <a:schemeClr val="accent1"/>
-          </a:lnRef>
-          <a:fillRef idx="3">
-            <a:schemeClr val="accent1"/>
-          </a:fillRef>
-          <a:effectRef idx="2">
-            <a:schemeClr val="accent1"/>
-          </a:effectRef>
-          <a:fontRef idx="minor">
-            <a:schemeClr val="lt1"/>
-          </a:fontRef>
-        </p:style>
-        <p:txBody>
-          <a:bodyPr rtlCol="0" anchor="ctr" wrap="square" lIns="109728" rIns="109728" tIns="54864" bIns="54864"/>
-          <a:lstStyle/>
-          <a:p>
-            <a:pPr algn="ctr">
+              <a:rPr sz="1200" b="1">
+                <a:solidFill>
+                  <a:srgbClr val="E0261E"/>
+                </a:solidFill>
+                <a:latin typeface="Arial"/>
+              </a:rPr>
+              <a:t>COMO CONFIAMOS</a:t>
+            </a:r>
+          </a:p>
+          <a:p>
+            <a:pPr>
+              <a:spcBef>
+                <a:spcPts val="600"/>
+              </a:spcBef>
               <a:spcAft>
-                <a:spcPts val="200"/>
+                <a:spcPts val="100"/>
               </a:spcAft>
             </a:pPr>
             <a:r>
-              <a:rPr sz="1500" b="1">
-                <a:solidFill>
-                  <a:srgbClr val="FFFFFF"/>
-                </a:solidFill>
-                <a:latin typeface="Arial"/>
-              </a:rPr>
-              <a:t>Conversa</a:t>
-            </a:r>
-          </a:p>
-        </p:txBody>
-      </p:sp>
-      <p:sp>
-        <p:nvSpPr>
-          <p:cNvPr id="133" name="Chevron 132"/>
-          <p:cNvSpPr/>
-          <p:nvPr/>
-        </p:nvSpPr>
-        <p:spPr>
-          <a:xfrm>
-            <a:off x="7004304" y="3291840"/>
-            <a:ext cx="365760" cy="320040"/>
-          </a:xfrm>
-          <a:prstGeom prst="chevron">
-            <a:avLst/>
-          </a:prstGeom>
-          <a:solidFill>
-            <a:srgbClr val="8A909C"/>
-          </a:solidFill>
-          <a:ln>
-            <a:noFill/>
-          </a:ln>
-          <a:effectLst/>
-        </p:spPr>
-        <p:style>
-          <a:lnRef idx="1">
-            <a:schemeClr val="accent1"/>
-          </a:lnRef>
-          <a:fillRef idx="3">
-            <a:schemeClr val="accent1"/>
-          </a:fillRef>
-          <a:effectRef idx="2">
-            <a:schemeClr val="accent1"/>
-          </a:effectRef>
-          <a:fontRef idx="minor">
-            <a:schemeClr val="lt1"/>
-          </a:fontRef>
-        </p:style>
-        <p:txBody>
-          <a:bodyPr rtlCol="0" anchor="ctr"/>
-          <a:lstStyle/>
-          <a:p>
-            <a:pPr algn="ctr"/>
-          </a:p>
-        </p:txBody>
-      </p:sp>
-      <p:sp>
-        <p:nvSpPr>
-          <p:cNvPr id="134" name="Rounded Rectangle 133"/>
-          <p:cNvSpPr/>
-          <p:nvPr/>
-        </p:nvSpPr>
-        <p:spPr>
-          <a:xfrm>
-            <a:off x="7278624" y="2926080"/>
-            <a:ext cx="1965960" cy="1051560"/>
-          </a:xfrm>
-          <a:prstGeom prst="roundRect">
-            <a:avLst/>
-          </a:prstGeom>
-          <a:solidFill>
-            <a:srgbClr val="E0261E"/>
-          </a:solidFill>
-          <a:ln>
-            <a:noFill/>
-          </a:ln>
-          <a:effectLst/>
-        </p:spPr>
-        <p:style>
-          <a:lnRef idx="1">
-            <a:schemeClr val="accent1"/>
-          </a:lnRef>
-          <a:fillRef idx="3">
-            <a:schemeClr val="accent1"/>
-          </a:fillRef>
-          <a:effectRef idx="2">
-            <a:schemeClr val="accent1"/>
-          </a:effectRef>
-          <a:fontRef idx="minor">
-            <a:schemeClr val="lt1"/>
-          </a:fontRef>
-        </p:style>
-        <p:txBody>
-          <a:bodyPr rtlCol="0" anchor="ctr" wrap="square" lIns="109728" rIns="109728" tIns="54864" bIns="54864"/>
-          <a:lstStyle/>
-          <a:p>
-            <a:pPr algn="ctr">
-              <a:spcAft>
-                <a:spcPts val="200"/>
-              </a:spcAft>
-            </a:pPr>
-            <a:r>
-              <a:rPr sz="1500" b="1">
-                <a:solidFill>
-                  <a:srgbClr val="FFFFFF"/>
-                </a:solidFill>
-                <a:latin typeface="Arial"/>
-              </a:rPr>
-              <a:t>Consolidação</a:t>
-            </a:r>
-          </a:p>
-          <a:p>
-            <a:pPr algn="ctr">
-              <a:spcAft>
-                <a:spcPts val="200"/>
-              </a:spcAft>
-            </a:pPr>
-            <a:r>
-              <a:rPr sz="1100" b="0">
-                <a:solidFill>
-                  <a:srgbClr val="FFFFFF"/>
-                </a:solidFill>
-                <a:latin typeface="Arial"/>
-              </a:rPr>
-              <a:t>com IA</a:t>
-            </a:r>
-          </a:p>
-        </p:txBody>
-      </p:sp>
-      <p:sp>
-        <p:nvSpPr>
-          <p:cNvPr id="135" name="Chevron 134"/>
-          <p:cNvSpPr/>
-          <p:nvPr/>
-        </p:nvSpPr>
-        <p:spPr>
-          <a:xfrm>
-            <a:off x="9262872" y="3291840"/>
-            <a:ext cx="365760" cy="320040"/>
-          </a:xfrm>
-          <a:prstGeom prst="chevron">
-            <a:avLst/>
-          </a:prstGeom>
-          <a:solidFill>
-            <a:srgbClr val="8A909C"/>
-          </a:solidFill>
-          <a:ln>
-            <a:noFill/>
-          </a:ln>
-          <a:effectLst/>
-        </p:spPr>
-        <p:style>
-          <a:lnRef idx="1">
-            <a:schemeClr val="accent1"/>
-          </a:lnRef>
-          <a:fillRef idx="3">
-            <a:schemeClr val="accent1"/>
-          </a:fillRef>
-          <a:effectRef idx="2">
-            <a:schemeClr val="accent1"/>
-          </a:effectRef>
-          <a:fontRef idx="minor">
-            <a:schemeClr val="lt1"/>
-          </a:fontRef>
-        </p:style>
-        <p:txBody>
-          <a:bodyPr rtlCol="0" anchor="ctr"/>
-          <a:lstStyle/>
-          <a:p>
-            <a:pPr algn="ctr"/>
-          </a:p>
-        </p:txBody>
-      </p:sp>
-      <p:sp>
-        <p:nvSpPr>
-          <p:cNvPr id="136" name="Rounded Rectangle 135"/>
-          <p:cNvSpPr/>
-          <p:nvPr/>
-        </p:nvSpPr>
-        <p:spPr>
-          <a:xfrm>
-            <a:off x="9537192" y="2926080"/>
-            <a:ext cx="1965960" cy="1051560"/>
-          </a:xfrm>
-          <a:prstGeom prst="roundRect">
-            <a:avLst/>
-          </a:prstGeom>
-          <a:solidFill>
-            <a:srgbClr val="1F2A44"/>
-          </a:solidFill>
-          <a:ln>
-            <a:noFill/>
-          </a:ln>
-          <a:effectLst/>
-        </p:spPr>
-        <p:style>
-          <a:lnRef idx="1">
-            <a:schemeClr val="accent1"/>
-          </a:lnRef>
-          <a:fillRef idx="3">
-            <a:schemeClr val="accent1"/>
-          </a:fillRef>
-          <a:effectRef idx="2">
-            <a:schemeClr val="accent1"/>
-          </a:effectRef>
-          <a:fontRef idx="minor">
-            <a:schemeClr val="lt1"/>
-          </a:fontRef>
-        </p:style>
-        <p:txBody>
-          <a:bodyPr rtlCol="0" anchor="ctr" wrap="square" lIns="109728" rIns="109728" tIns="54864" bIns="54864"/>
-          <a:lstStyle/>
-          <a:p>
-            <a:pPr algn="ctr">
-              <a:spcAft>
-                <a:spcPts val="200"/>
-              </a:spcAft>
-            </a:pPr>
-            <a:r>
-              <a:rPr sz="1500" b="1">
-                <a:solidFill>
-                  <a:srgbClr val="FFFFFF"/>
-                </a:solidFill>
-                <a:latin typeface="Arial"/>
-              </a:rPr>
-              <a:t>Reuso</a:t>
-            </a:r>
-          </a:p>
-        </p:txBody>
-      </p:sp>
-      <p:sp>
-        <p:nvSpPr>
-          <p:cNvPr id="137" name="TextBox 136"/>
-          <p:cNvSpPr txBox="1"/>
-          <p:nvPr/>
-        </p:nvSpPr>
-        <p:spPr>
-          <a:xfrm>
-            <a:off x="502920" y="4572000"/>
-            <a:ext cx="10972800" cy="457200"/>
-          </a:xfrm>
-          <a:prstGeom prst="rect">
-            <a:avLst/>
-          </a:prstGeom>
-          <a:noFill/>
-        </p:spPr>
-        <p:txBody>
-          <a:bodyPr wrap="square" anchor="t">
-            <a:spAutoFit/>
-          </a:bodyPr>
-          <a:lstStyle/>
-          <a:p>
-            <a:pPr algn="l">
+              <a:rPr sz="1450" b="1">
+                <a:solidFill>
+                  <a:srgbClr val="1F2A44"/>
+                </a:solidFill>
+                <a:latin typeface="Arial"/>
+              </a:rPr>
+              <a:t>A IA propõe, o humano decide</a:t>
+            </a:r>
+          </a:p>
+          <a:p>
+            <a:pPr>
               <a:spcAft>
                 <a:spcPts val="400"/>
               </a:spcAft>
             </a:pPr>
             <a:r>
-              <a:rPr sz="1600" b="0" i="0">
+              <a:rPr sz="1250">
                 <a:solidFill>
                   <a:srgbClr val="5B6372"/>
                 </a:solidFill>
                 <a:latin typeface="Arial"/>
               </a:rPr>
-              <a:t>A IA acelera as pontas trabalhosas; o consultor decide.</a:t>
+              <a:t>Nunca escreve direto: o consultor revisa e publica</a:t>
+            </a:r>
+          </a:p>
+          <a:p>
+            <a:pPr>
+              <a:spcBef>
+                <a:spcPts val="600"/>
+              </a:spcBef>
+              <a:spcAft>
+                <a:spcPts val="100"/>
+              </a:spcAft>
+            </a:pPr>
+            <a:r>
+              <a:rPr sz="1450" b="1">
+                <a:solidFill>
+                  <a:srgbClr val="1F2A44"/>
+                </a:solidFill>
+                <a:latin typeface="Arial"/>
+              </a:rPr>
+              <a:t>Grounding no MPO + saída estruturada</a:t>
+            </a:r>
+          </a:p>
+          <a:p>
+            <a:pPr>
+              <a:spcAft>
+                <a:spcPts val="400"/>
+              </a:spcAft>
+            </a:pPr>
+            <a:r>
+              <a:rPr sz="1250">
+                <a:solidFill>
+                  <a:srgbClr val="5B6372"/>
+                </a:solidFill>
+                <a:latin typeface="Arial"/>
+              </a:rPr>
+              <a:t>Responde no formato de dados e não inventa atributos</a:t>
+            </a:r>
+          </a:p>
+          <a:p>
+            <a:pPr>
+              <a:spcBef>
+                <a:spcPts val="600"/>
+              </a:spcBef>
+              <a:spcAft>
+                <a:spcPts val="100"/>
+              </a:spcAft>
+            </a:pPr>
+            <a:r>
+              <a:rPr sz="1450" b="1">
+                <a:solidFill>
+                  <a:srgbClr val="1F2A44"/>
+                </a:solidFill>
+                <a:latin typeface="Arial"/>
+              </a:rPr>
+              <a:t>Proveniência registrada</a:t>
+            </a:r>
+          </a:p>
+          <a:p>
+            <a:pPr>
+              <a:spcAft>
+                <a:spcPts val="400"/>
+              </a:spcAft>
+            </a:pPr>
+            <a:r>
+              <a:rPr sz="1250">
+                <a:solidFill>
+                  <a:srgbClr val="5B6372"/>
+                </a:solidFill>
+                <a:latin typeface="Arial"/>
+              </a:rPr>
+              <a:t>Cada sugestão guarda provedor, modelo e momento</a:t>
             </a:r>
           </a:p>
         </p:txBody>
@@ -8202,7 +7126,7 @@
                 </a:solidFill>
                 <a:latin typeface="Arial"/>
               </a:rPr>
-              <a:t>6 / 12</a:t>
+              <a:t>6 / 11</a:t>
             </a:r>
           </a:p>
         </p:txBody>
@@ -8255,7 +7179,7 @@
         <p:spPr>
           <a:xfrm>
             <a:off x="502920" y="804672"/>
-            <a:ext cx="10241280" cy="914400"/>
+            <a:ext cx="11155680" cy="914400"/>
           </a:xfrm>
           <a:prstGeom prst="rect">
             <a:avLst/>
@@ -8503,7 +7427,7 @@
                 </a:solidFill>
                 <a:latin typeface="Arial"/>
               </a:rPr>
-              <a:t>7 / 12</a:t>
+              <a:t>7 / 11</a:t>
             </a:r>
           </a:p>
         </p:txBody>
@@ -8580,7 +7504,7 @@
         <p:spPr>
           <a:xfrm>
             <a:off x="502920" y="804672"/>
-            <a:ext cx="10241280" cy="914400"/>
+            <a:ext cx="11155680" cy="914400"/>
           </a:xfrm>
           <a:prstGeom prst="rect">
             <a:avLst/>
@@ -8618,7 +7542,7 @@
         </p:nvSpPr>
         <p:spPr>
           <a:xfrm>
-            <a:off x="502920" y="1783080"/>
+            <a:off x="502920" y="1737360"/>
             <a:ext cx="11155680" cy="365760"/>
           </a:xfrm>
           <a:prstGeom prst="rect">
@@ -8769,7 +7693,7 @@
                 </a:solidFill>
                 <a:latin typeface="Arial"/>
               </a:rPr>
-              <a:t>8 / 12</a:t>
+              <a:t>8 / 11</a:t>
             </a:r>
           </a:p>
         </p:txBody>
@@ -8832,7 +7756,7 @@
                 </a:solidFill>
                 <a:latin typeface="Arial"/>
               </a:rPr>
-              <a:t>IA COM REVISÃO HUMANA</a:t>
+              <a:t>O EXPERIMENTO</a:t>
             </a:r>
           </a:p>
         </p:txBody>
@@ -8846,7 +7770,7 @@
         <p:spPr>
           <a:xfrm>
             <a:off x="502920" y="804672"/>
-            <a:ext cx="10241280" cy="914400"/>
+            <a:ext cx="11155680" cy="914400"/>
           </a:xfrm>
           <a:prstGeom prst="rect">
             <a:avLst/>
@@ -8871,7 +7795,7 @@
                 </a:solidFill>
                 <a:latin typeface="Arial"/>
               </a:rPr>
-              <a:t>A IA sugere, o humano decide</a:t>
+              <a:t>Design Science Research, avaliado em uso real</a:t>
             </a:r>
           </a:p>
         </p:txBody>
@@ -8884,14 +7808,14 @@
         </p:nvSpPr>
         <p:spPr>
           <a:xfrm>
-            <a:off x="914400" y="2880360"/>
-            <a:ext cx="2834640" cy="1234440"/>
+            <a:off x="822960" y="2148840"/>
+            <a:ext cx="2926080" cy="1051560"/>
           </a:xfrm>
           <a:prstGeom prst="roundRect">
             <a:avLst/>
           </a:prstGeom>
           <a:solidFill>
-            <a:srgbClr val="E0261E"/>
+            <a:srgbClr val="1F2A44"/>
           </a:solidFill>
           <a:ln>
             <a:noFill/>
@@ -8913,38 +7837,38 @@
           </a:fontRef>
         </p:style>
         <p:txBody>
-          <a:bodyPr rtlCol="0" anchor="ctr" wrap="square" lIns="109728" rIns="109728" tIns="54864" bIns="54864"/>
+          <a:bodyPr rtlCol="0" anchor="ctr" wrap="square" lIns="128016" rIns="128016" tIns="54864" bIns="54864"/>
           <a:lstStyle/>
           <a:p>
             <a:pPr algn="ctr">
               <a:spcAft>
-                <a:spcPts val="200"/>
+                <a:spcPts val="300"/>
               </a:spcAft>
             </a:pPr>
             <a:r>
-              <a:rPr sz="1600" b="1">
+              <a:rPr sz="1500" b="1">
                 <a:solidFill>
                   <a:srgbClr val="FFFFFF"/>
                 </a:solidFill>
                 <a:latin typeface="Arial"/>
               </a:rPr>
-              <a:t>IA propõe</a:t>
+              <a:t>Construir</a:t>
             </a:r>
           </a:p>
           <a:p>
             <a:pPr algn="ctr">
               <a:spcAft>
-                <a:spcPts val="200"/>
+                <a:spcPts val="300"/>
               </a:spcAft>
             </a:pPr>
             <a:r>
-              <a:rPr sz="1600" b="1">
+              <a:rPr sz="1500" b="1">
                 <a:solidFill>
                   <a:srgbClr val="FFFFFF"/>
                 </a:solidFill>
                 <a:latin typeface="Arial"/>
               </a:rPr>
-              <a:t>o rascunho</a:t>
+              <a:t>o artefato</a:t>
             </a:r>
           </a:p>
         </p:txBody>
@@ -8957,8 +7881,8 @@
         </p:nvSpPr>
         <p:spPr>
           <a:xfrm>
-            <a:off x="3767327" y="3319272"/>
-            <a:ext cx="502920" cy="365760"/>
+            <a:off x="3767328" y="2514600"/>
+            <a:ext cx="502920" cy="329184"/>
           </a:xfrm>
           <a:prstGeom prst="chevron">
             <a:avLst/>
@@ -9001,8 +7925,8 @@
         </p:nvSpPr>
         <p:spPr>
           <a:xfrm>
-            <a:off x="4663440" y="2880360"/>
-            <a:ext cx="2834640" cy="1234440"/>
+            <a:off x="4626864" y="2148840"/>
+            <a:ext cx="2926080" cy="1051560"/>
           </a:xfrm>
           <a:prstGeom prst="roundRect">
             <a:avLst/>
@@ -9030,38 +7954,38 @@
           </a:fontRef>
         </p:style>
         <p:txBody>
-          <a:bodyPr rtlCol="0" anchor="ctr" wrap="square" lIns="109728" rIns="109728" tIns="54864" bIns="54864"/>
+          <a:bodyPr rtlCol="0" anchor="ctr" wrap="square" lIns="128016" rIns="128016" tIns="54864" bIns="54864"/>
           <a:lstStyle/>
           <a:p>
             <a:pPr algn="ctr">
               <a:spcAft>
-                <a:spcPts val="200"/>
+                <a:spcPts val="300"/>
               </a:spcAft>
             </a:pPr>
             <a:r>
-              <a:rPr sz="1600" b="1">
+              <a:rPr sz="1500" b="1">
                 <a:solidFill>
                   <a:srgbClr val="FFFFFF"/>
                 </a:solidFill>
                 <a:latin typeface="Arial"/>
               </a:rPr>
-              <a:t>O consultor</a:t>
+              <a:t>Demonstrar</a:t>
             </a:r>
           </a:p>
           <a:p>
             <a:pPr algn="ctr">
               <a:spcAft>
-                <a:spcPts val="200"/>
+                <a:spcPts val="300"/>
               </a:spcAft>
             </a:pPr>
             <a:r>
-              <a:rPr sz="1600" b="1">
+              <a:rPr sz="1500" b="1">
                 <a:solidFill>
                   <a:srgbClr val="FFFFFF"/>
                 </a:solidFill>
                 <a:latin typeface="Arial"/>
               </a:rPr>
-              <a:t>revisa</a:t>
+              <a:t>em uso real</a:t>
             </a:r>
           </a:p>
         </p:txBody>
@@ -9074,8 +7998,8 @@
         </p:nvSpPr>
         <p:spPr>
           <a:xfrm>
-            <a:off x="7516367" y="3319272"/>
-            <a:ext cx="502920" cy="365760"/>
+            <a:off x="7571231" y="2514600"/>
+            <a:ext cx="502920" cy="329184"/>
           </a:xfrm>
           <a:prstGeom prst="chevron">
             <a:avLst/>
@@ -9118,8 +8042,8 @@
         </p:nvSpPr>
         <p:spPr>
           <a:xfrm>
-            <a:off x="8412480" y="2880360"/>
-            <a:ext cx="2834640" cy="1234440"/>
+            <a:off x="8430768" y="2148840"/>
+            <a:ext cx="2926080" cy="1051560"/>
           </a:xfrm>
           <a:prstGeom prst="roundRect">
             <a:avLst/>
@@ -9147,52 +8071,202 @@
           </a:fontRef>
         </p:style>
         <p:txBody>
-          <a:bodyPr rtlCol="0" anchor="ctr" wrap="square" lIns="109728" rIns="109728" tIns="54864" bIns="54864"/>
+          <a:bodyPr rtlCol="0" anchor="ctr" wrap="square" lIns="128016" rIns="128016" tIns="54864" bIns="54864"/>
           <a:lstStyle/>
           <a:p>
             <a:pPr algn="ctr">
               <a:spcAft>
-                <a:spcPts val="200"/>
+                <a:spcPts val="300"/>
               </a:spcAft>
             </a:pPr>
             <a:r>
-              <a:rPr sz="1600" b="1">
+              <a:rPr sz="1500" b="1">
                 <a:solidFill>
                   <a:srgbClr val="FFFFFF"/>
                 </a:solidFill>
                 <a:latin typeface="Arial"/>
               </a:rPr>
-              <a:t>Publicado</a:t>
+              <a:t>Avaliar</a:t>
             </a:r>
           </a:p>
           <a:p>
             <a:pPr algn="ctr">
               <a:spcAft>
-                <a:spcPts val="200"/>
+                <a:spcPts val="300"/>
               </a:spcAft>
             </a:pPr>
             <a:r>
-              <a:rPr sz="1600" b="1">
+              <a:rPr sz="1500" b="1">
                 <a:solidFill>
                   <a:srgbClr val="FFFFFF"/>
                 </a:solidFill>
                 <a:latin typeface="Arial"/>
               </a:rPr>
-              <a:t>e auditável</a:t>
-            </a:r>
-          </a:p>
-        </p:txBody>
-      </p:sp>
-      <p:sp>
-        <p:nvSpPr>
-          <p:cNvPr id="48" name="TextBox 47"/>
+              <a:t>a percepção</a:t>
+            </a:r>
+          </a:p>
+        </p:txBody>
+      </p:sp>
+      <p:sp>
+        <p:nvSpPr>
+          <p:cNvPr id="48" name="Rounded Rectangle 47"/>
+          <p:cNvSpPr/>
+          <p:nvPr/>
+        </p:nvSpPr>
+        <p:spPr>
+          <a:xfrm>
+            <a:off x="822960" y="3657600"/>
+            <a:ext cx="5074920" cy="1417320"/>
+          </a:xfrm>
+          <a:prstGeom prst="roundRect">
+            <a:avLst/>
+          </a:prstGeom>
+          <a:solidFill>
+            <a:srgbClr val="F6F7F9"/>
+          </a:solidFill>
+          <a:ln w="12700">
+            <a:solidFill>
+              <a:srgbClr val="DDE1E7"/>
+            </a:solidFill>
+          </a:ln>
+          <a:effectLst/>
+        </p:spPr>
+        <p:style>
+          <a:lnRef idx="1">
+            <a:schemeClr val="accent1"/>
+          </a:lnRef>
+          <a:fillRef idx="3">
+            <a:schemeClr val="accent1"/>
+          </a:fillRef>
+          <a:effectRef idx="2">
+            <a:schemeClr val="accent1"/>
+          </a:effectRef>
+          <a:fontRef idx="minor">
+            <a:schemeClr val="lt1"/>
+          </a:fontRef>
+        </p:style>
+        <p:txBody>
+          <a:bodyPr rtlCol="0" anchor="ctr" wrap="square" lIns="128016" rIns="128016" tIns="54864" bIns="54864"/>
+          <a:lstStyle/>
+          <a:p>
+            <a:pPr algn="ctr">
+              <a:spcAft>
+                <a:spcPts val="300"/>
+              </a:spcAft>
+            </a:pPr>
+            <a:r>
+              <a:rPr sz="1450" b="1">
+                <a:solidFill>
+                  <a:srgbClr val="E0261E"/>
+                </a:solidFill>
+                <a:latin typeface="Arial"/>
+              </a:rPr>
+              <a:t>Instrumento</a:t>
+            </a:r>
+          </a:p>
+          <a:p>
+            <a:pPr algn="ctr">
+              <a:spcAft>
+                <a:spcPts val="300"/>
+              </a:spcAft>
+            </a:pPr>
+            <a:r>
+              <a:rPr sz="1300" b="0">
+                <a:solidFill>
+                  <a:srgbClr val="1F2A44"/>
+                </a:solidFill>
+                <a:latin typeface="Arial"/>
+              </a:rPr>
+              <a:t>12 afirmações Likert (1 a 5) e 3 perguntas abertas, após um walkthrough</a:t>
+            </a:r>
+          </a:p>
+        </p:txBody>
+      </p:sp>
+      <p:sp>
+        <p:nvSpPr>
+          <p:cNvPr id="49" name="Rounded Rectangle 48"/>
+          <p:cNvSpPr/>
+          <p:nvPr/>
+        </p:nvSpPr>
+        <p:spPr>
+          <a:xfrm>
+            <a:off x="6263640" y="3657600"/>
+            <a:ext cx="5074920" cy="1417320"/>
+          </a:xfrm>
+          <a:prstGeom prst="roundRect">
+            <a:avLst/>
+          </a:prstGeom>
+          <a:solidFill>
+            <a:srgbClr val="F6F7F9"/>
+          </a:solidFill>
+          <a:ln w="12700">
+            <a:solidFill>
+              <a:srgbClr val="DDE1E7"/>
+            </a:solidFill>
+          </a:ln>
+          <a:effectLst/>
+        </p:spPr>
+        <p:style>
+          <a:lnRef idx="1">
+            <a:schemeClr val="accent1"/>
+          </a:lnRef>
+          <a:fillRef idx="3">
+            <a:schemeClr val="accent1"/>
+          </a:fillRef>
+          <a:effectRef idx="2">
+            <a:schemeClr val="accent1"/>
+          </a:effectRef>
+          <a:fontRef idx="minor">
+            <a:schemeClr val="lt1"/>
+          </a:fontRef>
+        </p:style>
+        <p:txBody>
+          <a:bodyPr rtlCol="0" anchor="ctr" wrap="square" lIns="128016" rIns="128016" tIns="54864" bIns="54864"/>
+          <a:lstStyle/>
+          <a:p>
+            <a:pPr algn="ctr">
+              <a:spcAft>
+                <a:spcPts val="300"/>
+              </a:spcAft>
+            </a:pPr>
+            <a:r>
+              <a:rPr sz="1450" b="1">
+                <a:solidFill>
+                  <a:srgbClr val="E0261E"/>
+                </a:solidFill>
+                <a:latin typeface="Arial"/>
+              </a:rPr>
+              <a:t>Amostra</a:t>
+            </a:r>
+          </a:p>
+          <a:p>
+            <a:pPr algn="ctr">
+              <a:spcAft>
+                <a:spcPts val="300"/>
+              </a:spcAft>
+            </a:pPr>
+            <a:r>
+              <a:rPr sz="1300" b="0">
+                <a:solidFill>
+                  <a:srgbClr val="1F2A44"/>
+                </a:solidFill>
+                <a:latin typeface="Arial"/>
+              </a:rPr>
+              <a:t>2 rodadas de 4 consultores (N=8), uma consultoria real; 2ª rodada após onboarding</a:t>
+            </a:r>
+          </a:p>
+        </p:txBody>
+      </p:sp>
+      <p:sp>
+        <p:nvSpPr>
+          <p:cNvPr id="50" name="TextBox 49"/>
           <p:cNvSpPr txBox="1"/>
           <p:nvPr/>
         </p:nvSpPr>
         <p:spPr>
           <a:xfrm>
-            <a:off x="502920" y="4617720"/>
-            <a:ext cx="10972800" cy="548640"/>
+            <a:off x="822960" y="5257800"/>
+            <a:ext cx="10515600" cy="457200"/>
           </a:xfrm>
           <a:prstGeom prst="rect">
             <a:avLst/>
@@ -9211,13 +8285,13 @@
               </a:spcAft>
             </a:pPr>
             <a:r>
-              <a:rPr sz="1500" b="0" i="0">
-                <a:solidFill>
-                  <a:srgbClr val="5B6372"/>
-                </a:solidFill>
-                <a:latin typeface="Arial"/>
-              </a:rPr>
-              <a:t>A IA nunca escreve direto: propõe, o consultor publica. Cada sugestão fica registrada com provedor, modelo e momento.</a:t>
+              <a:rPr sz="1300" b="0" i="1">
+                <a:solidFill>
+                  <a:srgbClr val="8A909C"/>
+                </a:solidFill>
+                <a:latin typeface="Arial"/>
+              </a:rPr>
+              <a:t>Perspectiva do consultor. Reportado como casos, sem inferência estatística.</a:t>
             </a:r>
           </a:p>
         </p:txBody>
@@ -9313,7 +8387,7 @@
                 </a:solidFill>
                 <a:latin typeface="Arial"/>
               </a:rPr>
-              <a:t>9 / 12</a:t>
+              <a:t>9 / 11</a:t>
             </a:r>
           </a:p>
         </p:txBody>
@@ -9376,7 +8450,7 @@
                 </a:solidFill>
                 <a:latin typeface="Arial"/>
               </a:rPr>
-              <a:t>VALIDAÇÃO</a:t>
+              <a:t>RESULTADOS</a:t>
             </a:r>
           </a:p>
         </p:txBody>
@@ -9390,7 +8464,7 @@
         <p:spPr>
           <a:xfrm>
             <a:off x="502920" y="804672"/>
-            <a:ext cx="10241280" cy="914400"/>
+            <a:ext cx="11155680" cy="914400"/>
           </a:xfrm>
           <a:prstGeom prst="rect">
             <a:avLst/>
@@ -9415,60 +8489,21 @@
                 </a:solidFill>
                 <a:latin typeface="Arial"/>
               </a:rPr>
-              <a:t>Valor percebido, com um alerta honesto</a:t>
-            </a:r>
-          </a:p>
-        </p:txBody>
-      </p:sp>
-      <p:sp>
-        <p:nvSpPr>
-          <p:cNvPr id="43" name="TextBox 42"/>
-          <p:cNvSpPr txBox="1"/>
-          <p:nvPr/>
-        </p:nvSpPr>
-        <p:spPr>
-          <a:xfrm>
-            <a:off x="502920" y="1783080"/>
-            <a:ext cx="10972800" cy="365760"/>
-          </a:xfrm>
-          <a:prstGeom prst="rect">
-            <a:avLst/>
-          </a:prstGeom>
-          <a:noFill/>
-        </p:spPr>
-        <p:txBody>
-          <a:bodyPr wrap="square" anchor="t">
-            <a:spAutoFit/>
-          </a:bodyPr>
-          <a:lstStyle/>
-          <a:p>
-            <a:pPr algn="l">
-              <a:spcAft>
-                <a:spcPts val="400"/>
-              </a:spcAft>
-            </a:pPr>
-            <a:r>
-              <a:rPr sz="1500" b="0" i="0">
-                <a:solidFill>
-                  <a:srgbClr val="5B6372"/>
-                </a:solidFill>
-                <a:latin typeface="Arial"/>
-              </a:rPr>
-              <a:t>Design Science Research, reportado como casos (sem inferência estatística).</a:t>
-            </a:r>
-          </a:p>
-        </p:txBody>
-      </p:sp>
-      <p:sp>
-        <p:nvSpPr>
-          <p:cNvPr id="44" name="Rounded Rectangle 43"/>
+              <a:t>Valor percebido, com um ponto de atenção</a:t>
+            </a:r>
+          </a:p>
+        </p:txBody>
+      </p:sp>
+      <p:sp>
+        <p:nvSpPr>
+          <p:cNvPr id="43" name="Rounded Rectangle 42"/>
           <p:cNvSpPr/>
           <p:nvPr/>
         </p:nvSpPr>
         <p:spPr>
           <a:xfrm>
-            <a:off x="502920" y="2697480"/>
-            <a:ext cx="3520440" cy="2286000"/>
+            <a:off x="502920" y="2148840"/>
+            <a:ext cx="3520440" cy="1965960"/>
           </a:xfrm>
           <a:prstGeom prst="roundRect">
             <a:avLst/>
@@ -9498,58 +8533,29 @@
           </a:fontRef>
         </p:style>
         <p:txBody>
-          <a:bodyPr rtlCol="0" anchor="ctr" wrap="square" lIns="109728" rIns="109728" tIns="54864" bIns="54864"/>
-          <a:lstStyle/>
-          <a:p>
-            <a:pPr algn="ctr">
-              <a:spcAft>
-                <a:spcPts val="200"/>
-              </a:spcAft>
-            </a:pPr>
-            <a:r>
-              <a:rPr sz="4600" b="1">
-                <a:solidFill>
-                  <a:srgbClr val="1F2A44"/>
-                </a:solidFill>
-                <a:latin typeface="Arial"/>
-              </a:rPr>
-              <a:t>N = 8</a:t>
-            </a:r>
-          </a:p>
-          <a:p>
-            <a:pPr algn="ctr">
-              <a:spcAft>
-                <a:spcPts val="200"/>
-              </a:spcAft>
-            </a:pPr>
-            <a:r>
-              <a:rPr sz="1350" b="0">
-                <a:solidFill>
-                  <a:srgbClr val="5B6372"/>
-                </a:solidFill>
-                <a:latin typeface="Arial"/>
-              </a:rPr>
-              <a:t>participantes · duas rodadas</a:t>
-            </a:r>
-          </a:p>
-        </p:txBody>
-      </p:sp>
-      <p:sp>
-        <p:nvSpPr>
-          <p:cNvPr id="45" name="Rectangle 44"/>
+          <a:bodyPr rtlCol="0" anchor="ctr"/>
+          <a:lstStyle/>
+          <a:p>
+            <a:pPr algn="ctr"/>
+          </a:p>
+        </p:txBody>
+      </p:sp>
+      <p:sp>
+        <p:nvSpPr>
+          <p:cNvPr id="44" name="Rectangle 43"/>
           <p:cNvSpPr/>
           <p:nvPr/>
         </p:nvSpPr>
         <p:spPr>
           <a:xfrm>
-            <a:off x="502920" y="2697480"/>
+            <a:off x="502920" y="2148840"/>
             <a:ext cx="3520440" cy="109728"/>
           </a:xfrm>
           <a:prstGeom prst="rect">
             <a:avLst/>
           </a:prstGeom>
           <a:solidFill>
-            <a:srgbClr val="1F2A44"/>
+            <a:srgbClr val="2E7D5B"/>
           </a:solidFill>
           <a:ln>
             <a:noFill/>
@@ -9580,14 +8586,69 @@
       </p:sp>
       <p:sp>
         <p:nvSpPr>
+          <p:cNvPr id="45" name="TextBox 44"/>
+          <p:cNvSpPr txBox="1"/>
+          <p:nvPr/>
+        </p:nvSpPr>
+        <p:spPr>
+          <a:xfrm>
+            <a:off x="502920" y="2404872"/>
+            <a:ext cx="3520440" cy="1600200"/>
+          </a:xfrm>
+          <a:prstGeom prst="rect">
+            <a:avLst/>
+          </a:prstGeom>
+          <a:noFill/>
+        </p:spPr>
+        <p:txBody>
+          <a:bodyPr wrap="square" anchor="ctr">
+            <a:spAutoFit/>
+          </a:bodyPr>
+          <a:lstStyle/>
+          <a:p>
+            <a:pPr algn="ctr">
+              <a:spcAft>
+                <a:spcPts val="400"/>
+              </a:spcAft>
+            </a:pPr>
+            <a:r>
+              <a:rPr sz="4200" b="1" i="0">
+                <a:solidFill>
+                  <a:srgbClr val="1F2A44"/>
+                </a:solidFill>
+                <a:latin typeface="Arial"/>
+              </a:rPr>
+              <a:t>4,3 / 5</a:t>
+            </a:r>
+          </a:p>
+          <a:p>
+            <a:pPr algn="ctr">
+              <a:spcAft>
+                <a:spcPts val="400"/>
+              </a:spcAft>
+            </a:pPr>
+            <a:r>
+              <a:rPr sz="1300" b="0" i="0">
+                <a:solidFill>
+                  <a:srgbClr val="5B6372"/>
+                </a:solidFill>
+                <a:latin typeface="Arial"/>
+              </a:rPr>
+              <a:t>média acumulada (8 consultores)</a:t>
+            </a:r>
+          </a:p>
+        </p:txBody>
+      </p:sp>
+      <p:sp>
+        <p:nvSpPr>
           <p:cNvPr id="46" name="Rounded Rectangle 45"/>
           <p:cNvSpPr/>
           <p:nvPr/>
         </p:nvSpPr>
         <p:spPr>
           <a:xfrm>
-            <a:off x="4279392" y="2697480"/>
-            <a:ext cx="3520440" cy="2286000"/>
+            <a:off x="4279392" y="2148840"/>
+            <a:ext cx="3520440" cy="1965960"/>
           </a:xfrm>
           <a:prstGeom prst="roundRect">
             <a:avLst/>
@@ -9617,39 +8678,10 @@
           </a:fontRef>
         </p:style>
         <p:txBody>
-          <a:bodyPr rtlCol="0" anchor="ctr" wrap="square" lIns="109728" rIns="109728" tIns="54864" bIns="54864"/>
-          <a:lstStyle/>
-          <a:p>
-            <a:pPr algn="ctr">
-              <a:spcAft>
-                <a:spcPts val="200"/>
-              </a:spcAft>
-            </a:pPr>
-            <a:r>
-              <a:rPr sz="4600" b="1">
-                <a:solidFill>
-                  <a:srgbClr val="1F2A44"/>
-                </a:solidFill>
-                <a:latin typeface="Arial"/>
-              </a:rPr>
-              <a:t>5,0</a:t>
-            </a:r>
-          </a:p>
-          <a:p>
-            <a:pPr algn="ctr">
-              <a:spcAft>
-                <a:spcPts val="200"/>
-              </a:spcAft>
-            </a:pPr>
-            <a:r>
-              <a:rPr sz="1350" b="0">
-                <a:solidFill>
-                  <a:srgbClr val="5B6372"/>
-                </a:solidFill>
-                <a:latin typeface="Arial"/>
-              </a:rPr>
-              <a:t>governança e comunidade · nota máxima</a:t>
-            </a:r>
+          <a:bodyPr rtlCol="0" anchor="ctr"/>
+          <a:lstStyle/>
+          <a:p>
+            <a:pPr algn="ctr"/>
           </a:p>
         </p:txBody>
       </p:sp>
@@ -9661,14 +8693,14 @@
         </p:nvSpPr>
         <p:spPr>
           <a:xfrm>
-            <a:off x="4279392" y="2697480"/>
+            <a:off x="4279392" y="2148840"/>
             <a:ext cx="3520440" cy="109728"/>
           </a:xfrm>
           <a:prstGeom prst="rect">
             <a:avLst/>
           </a:prstGeom>
           <a:solidFill>
-            <a:srgbClr val="2E7D5B"/>
+            <a:srgbClr val="1F2A44"/>
           </a:solidFill>
           <a:ln>
             <a:noFill/>
@@ -9699,14 +8731,69 @@
       </p:sp>
       <p:sp>
         <p:nvSpPr>
-          <p:cNvPr id="48" name="Rounded Rectangle 47"/>
+          <p:cNvPr id="48" name="TextBox 47"/>
+          <p:cNvSpPr txBox="1"/>
+          <p:nvPr/>
+        </p:nvSpPr>
+        <p:spPr>
+          <a:xfrm>
+            <a:off x="4279392" y="2404872"/>
+            <a:ext cx="3520440" cy="1600200"/>
+          </a:xfrm>
+          <a:prstGeom prst="rect">
+            <a:avLst/>
+          </a:prstGeom>
+          <a:noFill/>
+        </p:spPr>
+        <p:txBody>
+          <a:bodyPr wrap="square" anchor="ctr">
+            <a:spAutoFit/>
+          </a:bodyPr>
+          <a:lstStyle/>
+          <a:p>
+            <a:pPr algn="ctr">
+              <a:spcAft>
+                <a:spcPts val="400"/>
+              </a:spcAft>
+            </a:pPr>
+            <a:r>
+              <a:rPr sz="4200" b="1" i="0">
+                <a:solidFill>
+                  <a:srgbClr val="1F2A44"/>
+                </a:solidFill>
+                <a:latin typeface="Arial"/>
+              </a:rPr>
+              <a:t>N = 8</a:t>
+            </a:r>
+          </a:p>
+          <a:p>
+            <a:pPr algn="ctr">
+              <a:spcAft>
+                <a:spcPts val="400"/>
+              </a:spcAft>
+            </a:pPr>
+            <a:r>
+              <a:rPr sz="1300" b="0" i="0">
+                <a:solidFill>
+                  <a:srgbClr val="5B6372"/>
+                </a:solidFill>
+                <a:latin typeface="Arial"/>
+              </a:rPr>
+              <a:t>2 rodadas de 4 · uma consultoria</a:t>
+            </a:r>
+          </a:p>
+        </p:txBody>
+      </p:sp>
+      <p:sp>
+        <p:nvSpPr>
+          <p:cNvPr id="49" name="Rounded Rectangle 48"/>
           <p:cNvSpPr/>
           <p:nvPr/>
         </p:nvSpPr>
         <p:spPr>
           <a:xfrm>
-            <a:off x="8055863" y="2697480"/>
-            <a:ext cx="3520440" cy="2286000"/>
+            <a:off x="8055863" y="2148840"/>
+            <a:ext cx="3520440" cy="1965960"/>
           </a:xfrm>
           <a:prstGeom prst="roundRect">
             <a:avLst/>
@@ -9736,58 +8823,29 @@
           </a:fontRef>
         </p:style>
         <p:txBody>
-          <a:bodyPr rtlCol="0" anchor="ctr" wrap="square" lIns="109728" rIns="109728" tIns="54864" bIns="54864"/>
-          <a:lstStyle/>
-          <a:p>
-            <a:pPr algn="ctr">
-              <a:spcAft>
-                <a:spcPts val="200"/>
-              </a:spcAft>
-            </a:pPr>
-            <a:r>
-              <a:rPr sz="4600" b="1">
-                <a:solidFill>
-                  <a:srgbClr val="1F2A44"/>
-                </a:solidFill>
-                <a:latin typeface="Arial"/>
-              </a:rPr>
-              <a:t>3,8</a:t>
-            </a:r>
-          </a:p>
-          <a:p>
-            <a:pPr algn="ctr">
-              <a:spcAft>
-                <a:spcPts val="200"/>
-              </a:spcAft>
-            </a:pPr>
-            <a:r>
-              <a:rPr sz="1350" b="0">
-                <a:solidFill>
-                  <a:srgbClr val="5B6372"/>
-                </a:solidFill>
-                <a:latin typeface="Arial"/>
-              </a:rPr>
-              <a:t>clareza · o ponto a evoluir</a:t>
-            </a:r>
-          </a:p>
-        </p:txBody>
-      </p:sp>
-      <p:sp>
-        <p:nvSpPr>
-          <p:cNvPr id="49" name="Rectangle 48"/>
+          <a:bodyPr rtlCol="0" anchor="ctr"/>
+          <a:lstStyle/>
+          <a:p>
+            <a:pPr algn="ctr"/>
+          </a:p>
+        </p:txBody>
+      </p:sp>
+      <p:sp>
+        <p:nvSpPr>
+          <p:cNvPr id="50" name="Rectangle 49"/>
           <p:cNvSpPr/>
           <p:nvPr/>
         </p:nvSpPr>
         <p:spPr>
           <a:xfrm>
-            <a:off x="8055863" y="2697480"/>
+            <a:off x="8055863" y="2148840"/>
             <a:ext cx="3520440" cy="109728"/>
           </a:xfrm>
           <a:prstGeom prst="rect">
             <a:avLst/>
           </a:prstGeom>
           <a:solidFill>
-            <a:srgbClr val="E0261E"/>
+            <a:srgbClr val="1F2A44"/>
           </a:solidFill>
           <a:ln>
             <a:noFill/>
@@ -9813,6 +8871,139 @@
           <a:lstStyle/>
           <a:p>
             <a:pPr algn="ctr"/>
+          </a:p>
+        </p:txBody>
+      </p:sp>
+      <p:sp>
+        <p:nvSpPr>
+          <p:cNvPr id="51" name="TextBox 50"/>
+          <p:cNvSpPr txBox="1"/>
+          <p:nvPr/>
+        </p:nvSpPr>
+        <p:spPr>
+          <a:xfrm>
+            <a:off x="8055863" y="2404872"/>
+            <a:ext cx="3520440" cy="1600200"/>
+          </a:xfrm>
+          <a:prstGeom prst="rect">
+            <a:avLst/>
+          </a:prstGeom>
+          <a:noFill/>
+        </p:spPr>
+        <p:txBody>
+          <a:bodyPr wrap="square" anchor="ctr">
+            <a:spAutoFit/>
+          </a:bodyPr>
+          <a:lstStyle/>
+          <a:p>
+            <a:pPr algn="ctr">
+              <a:spcAft>
+                <a:spcPts val="400"/>
+              </a:spcAft>
+            </a:pPr>
+            <a:r>
+              <a:rPr sz="4200" b="1" i="0">
+                <a:solidFill>
+                  <a:srgbClr val="1F2A44"/>
+                </a:solidFill>
+                <a:latin typeface="Arial"/>
+              </a:rPr>
+              <a:t>83%</a:t>
+            </a:r>
+          </a:p>
+          <a:p>
+            <a:pPr algn="ctr">
+              <a:spcAft>
+                <a:spcPts val="400"/>
+              </a:spcAft>
+            </a:pPr>
+            <a:r>
+              <a:rPr sz="1300" b="0" i="0">
+                <a:solidFill>
+                  <a:srgbClr val="5B6372"/>
+                </a:solidFill>
+                <a:latin typeface="Arial"/>
+              </a:rPr>
+              <a:t>das respostas foram nota 4 ou 5</a:t>
+            </a:r>
+          </a:p>
+        </p:txBody>
+      </p:sp>
+      <p:sp>
+        <p:nvSpPr>
+          <p:cNvPr id="52" name="TextBox 51"/>
+          <p:cNvSpPr txBox="1"/>
+          <p:nvPr/>
+        </p:nvSpPr>
+        <p:spPr>
+          <a:xfrm>
+            <a:off x="502920" y="4343400"/>
+            <a:ext cx="11247120" cy="640080"/>
+          </a:xfrm>
+          <a:prstGeom prst="rect">
+            <a:avLst/>
+          </a:prstGeom>
+          <a:noFill/>
+        </p:spPr>
+        <p:txBody>
+          <a:bodyPr wrap="square" anchor="t">
+            <a:spAutoFit/>
+          </a:bodyPr>
+          <a:lstStyle/>
+          <a:p>
+            <a:pPr algn="l">
+              <a:spcAft>
+                <a:spcPts val="400"/>
+              </a:spcAft>
+            </a:pPr>
+            <a:r>
+              <a:rPr sz="1500" b="0" i="0">
+                <a:solidFill>
+                  <a:srgbClr val="1F2A44"/>
+                </a:solidFill>
+                <a:latin typeface="Arial"/>
+              </a:rPr>
+              <a:t>1ª rodada 4,48; a 2ª foi mais crítica (4,1). Aprendizados e governança no topo (5,0 na 1ª rodada); clareza estável em 3,8, a fronteira de adoção.</a:t>
+            </a:r>
+          </a:p>
+        </p:txBody>
+      </p:sp>
+      <p:sp>
+        <p:nvSpPr>
+          <p:cNvPr id="53" name="TextBox 52"/>
+          <p:cNvSpPr txBox="1"/>
+          <p:nvPr/>
+        </p:nvSpPr>
+        <p:spPr>
+          <a:xfrm>
+            <a:off x="502920" y="5349240"/>
+            <a:ext cx="11247120" cy="548640"/>
+          </a:xfrm>
+          <a:prstGeom prst="rect">
+            <a:avLst/>
+          </a:prstGeom>
+          <a:noFill/>
+        </p:spPr>
+        <p:txBody>
+          <a:bodyPr wrap="square" anchor="t">
+            <a:spAutoFit/>
+          </a:bodyPr>
+          <a:lstStyle/>
+          <a:p>
+            <a:pPr algn="l">
+              <a:spcAft>
+                <a:spcPts val="400"/>
+              </a:spcAft>
+            </a:pPr>
+            <a:r>
+              <a:rPr sz="1350" b="0" i="1">
+                <a:solidFill>
+                  <a:srgbClr val="5B6372"/>
+                </a:solidFill>
+                <a:latin typeface="Arial"/>
+              </a:rPr>
+              <a:t>Nas respostas abertas o valor apareceu no aprendizado consolidado com IA; as críticas convergem para clareza e navegação.</a:t>
+            </a:r>
           </a:p>
         </p:txBody>
       </p:sp>

</xml_diff>

<commit_message>
docs(apresentacao): copy em tom academico (remove linguagem de pitch)
Troca girias/metaforas de venda (cliente com muralha, memoria viva, IA copiloto,
quem tem estrada) por linguagem sobria de seminario; traduz jargao (grounding,
walkthrough); corrige titulos (Metodo: DSR; Da proposta inicial ao observatorio)
e os headers do slide de desafios. QC PASS.

Co-Authored-By: Claude Opus 4.8 <noreply@anthropic.com>
</commit_message>
<xml_diff>
--- a/atividades/apresentacoes/ObiOne_Apresentacao_Final.pptx
+++ b/atividades/apresentacoes/ObiOne_Apresentacao_Final.pptx
@@ -4235,7 +4235,7 @@
                 </a:solidFill>
                 <a:latin typeface="Arial"/>
               </a:rPr>
-              <a:t>1ª rodada 4,48; a 2ª foi mais crítica (4,1). Aprendizados e governança no topo (5,0 na 1ª rodada); clareza estável em 3,8, a fronteira de adoção.</a:t>
+              <a:t>1ª rodada 4,48; a 2ª foi mais crítica (4,1). Aprendizados e governança no topo (5,0 na 1ª rodada); a clareza permaneceu em 3,8 e segue como o principal ponto de atenção.</a:t>
             </a:r>
           </a:p>
         </p:txBody>
@@ -4557,7 +4557,7 @@
                 </a:solidFill>
                 <a:latin typeface="Arial"/>
               </a:rPr>
-              <a:t>DESAFIOS</a:t>
+              <a:t>ESCOPO, MODELO E IA</a:t>
             </a:r>
           </a:p>
           <a:p>
@@ -4747,7 +4747,7 @@
                 </a:solidFill>
                 <a:latin typeface="Arial"/>
               </a:rPr>
-              <a:t>E MAIS</a:t>
+              <a:t>VALIDAÇÃO, ADOÇÃO E EQUIPE</a:t>
             </a:r>
           </a:p>
           <a:p>
@@ -5125,7 +5125,7 @@
                 </a:solidFill>
                 <a:latin typeface="Arial"/>
               </a:rPr>
-              <a:t>Isolamento do cliente</a:t>
+              <a:t>Isolamento entre clientes</a:t>
             </a:r>
           </a:p>
         </p:txBody>
@@ -5275,7 +5275,7 @@
                 </a:solidFill>
                 <a:latin typeface="Arial"/>
               </a:rPr>
-              <a:t>Engajamento</a:t>
+              <a:t>Engajamento do cliente</a:t>
             </a:r>
           </a:p>
         </p:txBody>
@@ -5350,7 +5350,7 @@
                 </a:solidFill>
                 <a:latin typeface="Arial"/>
               </a:rPr>
-              <a:t>IA copiloto</a:t>
+              <a:t>IA assistiva</a:t>
             </a:r>
           </a:p>
         </p:txBody>
@@ -5389,7 +5389,7 @@
                 </a:solidFill>
                 <a:latin typeface="Arial"/>
               </a:rPr>
-              <a:t>Replicável e demoável. </a:t>
+              <a:t>Ciclo completo, replicável e demonstrável ao vivo. </a:t>
             </a:r>
             <a:r>
               <a:rPr sz="1600" b="0" i="0">
@@ -5398,7 +5398,7 @@
                 </a:solidFill>
                 <a:latin typeface="Arial"/>
               </a:rPr>
-              <a:t>A seguir: navegação guiada e avaliação da fidelidade da extração do MPO.</a:t>
+              <a:t>Próximos passos: navegação guiada e avaliação da fidelidade da extração do MPO.</a:t>
             </a:r>
           </a:p>
         </p:txBody>
@@ -6940,7 +6940,7 @@
                 </a:solidFill>
                 <a:latin typeface="Arial"/>
               </a:rPr>
-              <a:t>O próximo projeto recomeça do zero</a:t>
+              <a:t>O que um projeto ensinou raramente chega ao próximo</a:t>
             </a:r>
           </a:p>
         </p:txBody>
@@ -6999,7 +6999,7 @@
                 </a:solidFill>
                 <a:latin typeface="Arial"/>
               </a:rPr>
-              <a:t>Depende sempre dos mesmos</a:t>
+              <a:t>Concentrado em poucos</a:t>
             </a:r>
           </a:p>
           <a:p>
@@ -7015,7 +7015,7 @@
                 </a:solidFill>
                 <a:latin typeface="Arial"/>
               </a:rPr>
-              <a:t>Só quem tem estrada liga os pontos entre projetos</a:t>
+              <a:t>A conexão entre projetos depende dos consultores mais experientes</a:t>
             </a:r>
           </a:p>
         </p:txBody>
@@ -7074,7 +7074,7 @@
                 </a:solidFill>
                 <a:latin typeface="Arial"/>
               </a:rPr>
-              <a:t>O cliente fica fora do laço</a:t>
+              <a:t>O cliente participa pouco</a:t>
             </a:r>
           </a:p>
           <a:p>
@@ -7090,7 +7090,7 @@
                 </a:solidFill>
                 <a:latin typeface="Arial"/>
               </a:rPr>
-              <a:t>E não dá para abrir tudo entre clientes</a:t>
+              <a:t>E abrir tudo comprometeria a confidencialidade entre clientes</a:t>
             </a:r>
           </a:p>
         </p:txBody>
@@ -7288,7 +7288,7 @@
                 </a:solidFill>
                 <a:latin typeface="Arial"/>
               </a:rPr>
-              <a:t>O projeto mudou no meio do caminho</a:t>
+              <a:t>Da proposta inicial ao observatório</a:t>
             </a:r>
           </a:p>
         </p:txBody>
@@ -7327,7 +7327,7 @@
                 </a:solidFill>
                 <a:latin typeface="Arial"/>
               </a:rPr>
-              <a:t>A proposta inicial foi reescopada após a crítica dos orientadores: refinar o propósito.</a:t>
+              <a:t>A crítica dos orientadores levou a um reescopo: refinar o propósito do artefato.</a:t>
             </a:r>
           </a:p>
         </p:txBody>
@@ -7503,7 +7503,7 @@
                 </a:solidFill>
                 <a:latin typeface="Arial"/>
               </a:rPr>
-              <a:t>Depois do pivô</a:t>
+              <a:t>Proposta refinada</a:t>
             </a:r>
           </a:p>
           <a:p>
@@ -7519,7 +7519,7 @@
                 </a:solidFill>
                 <a:latin typeface="Arial"/>
               </a:rPr>
-              <a:t>Observatório de projetos com o cliente dentro da comunidade</a:t>
+              <a:t>Observatório de projetos com participação do cliente na comunidade</a:t>
             </a:r>
           </a:p>
         </p:txBody>
@@ -7558,7 +7558,7 @@
                 </a:solidFill>
                 <a:latin typeface="Arial"/>
               </a:rPr>
-              <a:t>O refino deslocou o foco da extração para o ciclo de conhecimento e a participação segura do cliente, e definiu a pergunta: a IA generativa viabiliza um observatório de projetos?</a:t>
+              <a:t>O foco deslocou-se da extração de documentos para o ciclo de conhecimento, e a pergunta de pesquisa passou a ser: a IA generativa viabiliza um observatório de projetos?</a:t>
             </a:r>
           </a:p>
         </p:txBody>
@@ -7756,7 +7756,7 @@
                 </a:solidFill>
                 <a:latin typeface="Arial"/>
               </a:rPr>
-              <a:t>Design Science Research, avaliado em uso real</a:t>
+              <a:t>Método: Design Science Research</a:t>
             </a:r>
           </a:p>
         </p:txBody>
@@ -8138,7 +8138,7 @@
                 </a:solidFill>
                 <a:latin typeface="Arial"/>
               </a:rPr>
-              <a:t>12 afirmações Likert (1 a 5) e 3 perguntas abertas, após um walkthrough</a:t>
+              <a:t>12 afirmações em escala Likert (1 a 5) e 3 perguntas abertas, após demonstração guiada</a:t>
             </a:r>
           </a:p>
         </p:txBody>
@@ -8450,7 +8450,7 @@
                 </a:solidFill>
                 <a:latin typeface="Arial"/>
               </a:rPr>
-              <a:t>Um observatório que vira memória viva</a:t>
+              <a:t>O ciclo do conhecimento no observatório</a:t>
             </a:r>
           </a:p>
         </p:txBody>
@@ -8489,7 +8489,7 @@
                 </a:solidFill>
                 <a:latin typeface="Arial"/>
               </a:rPr>
-              <a:t>O ciclo do valor, ancorado no MPO (Vieira, 2022), com comunidade e IA assistiva.</a:t>
+              <a:t>Observações viram discussões na comunidade e se consolidam em conhecimento, ancorado no MPO (Vieira, 2022).</a:t>
             </a:r>
           </a:p>
         </p:txBody>
@@ -8807,7 +8807,7 @@
                 </a:solidFill>
                 <a:latin typeface="Arial"/>
               </a:rPr>
-              <a:t>Vira base de conhecimento reaproveitável por projetos futuros</a:t>
+              <a:t>O conhecimento consolidado fica disponível para os próximos projetos do domínio</a:t>
             </a:r>
           </a:p>
         </p:txBody>
@@ -9408,7 +9408,7 @@
                 </a:solidFill>
                 <a:latin typeface="Arial"/>
               </a:rPr>
-              <a:t>Grounding no MPO + saída estruturada</a:t>
+              <a:t>Ancorada no MPO, com saída estruturada</a:t>
             </a:r>
           </a:p>
           <a:p>
@@ -9424,7 +9424,7 @@
                 </a:solidFill>
                 <a:latin typeface="Arial"/>
               </a:rPr>
-              <a:t>Responde no formato de dados e não inventa atributos</a:t>
+              <a:t>A resposta segue um formato definido e usa apenas atributos do catálogo</a:t>
             </a:r>
           </a:p>
           <a:p>
@@ -9618,7 +9618,7 @@
                 </a:solidFill>
                 <a:latin typeface="Arial"/>
               </a:rPr>
-              <a:t>O DIFERENCIAL · CLIENTE COM MURALHA</a:t>
+              <a:t>O DIFERENCIAL · ACESSO SEMI-ABERTO</a:t>
             </a:r>
           </a:p>
         </p:txBody>
@@ -9657,7 +9657,7 @@
                 </a:solidFill>
                 <a:latin typeface="Arial"/>
               </a:rPr>
-              <a:t>O cliente dentro, sem ver os outros</a:t>
+              <a:t>O cliente participa, sem ver outros clientes</a:t>
             </a:r>
           </a:p>
         </p:txBody>
@@ -9734,7 +9734,7 @@
                 </a:solidFill>
                 <a:latin typeface="Arial"/>
               </a:rPr>
-              <a:t>Vê e acessa só o seu projeto</a:t>
+              <a:t>Vê e acessa apenas o próprio projeto</a:t>
             </a:r>
           </a:p>
           <a:p>
@@ -9759,7 +9759,7 @@
                 </a:solidFill>
                 <a:latin typeface="Arial"/>
               </a:rPr>
-              <a:t>Participa da conversa</a:t>
+              <a:t>Contribui nas conversas da comunidade</a:t>
             </a:r>
           </a:p>
           <a:p>
@@ -9784,7 +9784,7 @@
                 </a:solidFill>
                 <a:latin typeface="Arial"/>
               </a:rPr>
-              <a:t>As novidades o trazem de volta</a:t>
+              <a:t>As novidades do projeto o convidam a voltar</a:t>
             </a:r>
           </a:p>
         </p:txBody>
@@ -10021,7 +10021,7 @@
                 </a:solidFill>
                 <a:latin typeface="Arial"/>
               </a:rPr>
-              <a:t>Aprendizados de outros projetos afloram no domínio; a Conectora sintetiza padrões sob demanda.</a:t>
+              <a:t>Aprendizados consolidados em um projeto aparecem nos demais projetos do domínio; a Conectora sintetiza padrões sob demanda.</a:t>
             </a:r>
           </a:p>
         </p:txBody>

</xml_diff>